<commit_message>
Backlog y Scrumboard al día: tablero Kanban actualizado al 20/10 y estado en informe y PPT
- Nuevo Tablero_Kanban_NewBit_Actualizado (pptx, pdf, html): backlog con columna
  Estado, Scrumboard del Sprint 1 terminado y tablero de las historias del Sprint 2.
  El tablero de la semana 5 se conserva como plan.
- Informe: columna Estado en la tabla del backlog (FGAP060) y Figura 10 con el
  Scrumboard actualizado (40 págs.).
- PPT: lámina de backlog con S1 y S2 construidos y Scrumboard de hoy (lámina 28).

Co-Authored-By: Claude Sonnet 5.5 <noreply@anthropic.com>
</commit_message>
<xml_diff>
--- a/curso/semana-06-producto-unidad-1/nuestras-entregas/PPT_Producto_Unidad_1_NewBit/PPT_Producto_Unidad_1_NewBit.pptx
+++ b/curso/semana-06-producto-unidad-1/nuestras-entregas/PPT_Producto_Unidad_1_NewBit/PPT_Producto_Unidad_1_NewBit.pptx
@@ -1763,7 +1763,7 @@
           <a:p>
             <a:r>
               <a:rPr lang="en-US" dirty="0"/>
-              <a:t>Proceso 8.5: el backlog se ordena por valor, riesgo y dependencias. Tres pasos: MoSCoW, 100 puntos por integrante y dependencias. Resultado: 31 puntos en cuatro sprints.</a:t>
+              <a:t>Proceso 8.5: el backlog se ordena por valor, riesgo y dependencias. Tres pasos: MoSCoW, 100 puntos por integrante y dependencias. Resultado: 31 puntos en cuatro sprints. Al 20/10 ya están construidas las historias de los sprints 1 y 2 (15 puntos); el detalle va en la parte 4.</a:t>
             </a:r>
             <a:endParaRPr lang="en-US" dirty="0"/>
           </a:p>
@@ -1851,7 +1851,7 @@
           <a:p>
             <a:r>
               <a:rPr lang="en-US" dirty="0"/>
-              <a:t>Puño de cinco (proceso 9.2, p. 194): todos votan a la vez de 1 a 5; los extremos explican y se vota otra vez. A la derecha, el tablero del Sprint 1 con sus tareas propuestas (proceso 9.3).</a:t>
+              <a:t>Puño de cinco (proceso 9.2, p. 194): todos votan a la vez de 1 a 5; los extremos explican y se vota otra vez. A la derecha, el tablero del Sprint 1 tal como se planificó en la semana 5, con todo por hacer (proceso 9.3). Aclarar que ya avanzó: su estado de hoy está en la lámina 28.</a:t>
             </a:r>
             <a:endParaRPr lang="en-US" dirty="0"/>
           </a:p>
@@ -2291,7 +2291,7 @@
           <a:p>
             <a:r>
               <a:rPr lang="en-US" dirty="0"/>
-              <a:t>El estado de las 12 historias del backlog. Seis están hechas y esperan la aceptación del PO. HU05 agrupa los clips, pero le falta el formato de entrada del modelo temporal; se cierra junto con HU07. A la derecha, lo que exigen los criterios de terminado (FGAP070) y lo que todavía falta registrar.</a:t>
+              <a:t>El mismo tablero de la semana 5 (lámina 23), actualizado al 20/10 con las 12 historias. Seis están terminadas y esperan la aceptación del PO. La columna En prueba está vacía y no se muestra. HU05 agrupa los clips, pero le falta el formato de entrada del modelo temporal; se cierra junto con HU07. A la derecha, lo que exigen los criterios de terminado (FGAP070) y lo que todavía falta registrar.</a:t>
             </a:r>
             <a:endParaRPr lang="en-US" dirty="0"/>
           </a:p>
@@ -15728,17 +15728,17 @@
         <p:spPr>
           <a:xfrm>
             <a:off x="7086600" y="2926080"/>
-            <a:ext cx="2688336" cy="237744"/>
+            <a:ext cx="2304288" cy="237744"/>
           </a:xfrm>
           <a:prstGeom prst="rect">
             <a:avLst/>
           </a:prstGeom>
           <a:solidFill>
-            <a:srgbClr val="3E63DD"/>
+            <a:srgbClr val="2F855A"/>
           </a:solidFill>
           <a:ln w="12700">
             <a:solidFill>
-              <a:srgbClr val="3E63DD"/>
+              <a:srgbClr val="2F855A"/>
             </a:solidFill>
             <a:prstDash val="solid"/>
           </a:ln>
@@ -15752,7 +15752,7 @@
         </p:nvSpPr>
         <p:spPr>
           <a:xfrm>
-            <a:off x="9866376" y="2880360"/>
+            <a:off x="9482328" y="2880360"/>
             <a:ext cx="457200" cy="320040"/>
           </a:xfrm>
           <a:prstGeom prst="rect">
@@ -15785,102 +15785,26 @@
       </p:sp>
       <p:sp>
         <p:nvSpPr>
-          <p:cNvPr id="25" name="Text 22"/>
-          <p:cNvSpPr/>
-          <p:nvPr/>
-        </p:nvSpPr>
-        <p:spPr>
-          <a:xfrm>
-            <a:off x="7086600" y="3209544"/>
-            <a:ext cx="4389120" cy="274320"/>
-          </a:xfrm>
-          <a:prstGeom prst="rect">
-            <a:avLst/>
-          </a:prstGeom>
-          <a:noFill/>
-          <a:ln/>
-        </p:spPr>
-        <p:txBody>
-          <a:bodyPr wrap="square" lIns="0" tIns="0" rIns="0" bIns="0" rtlCol="0" anchor="t"/>
-          <a:lstStyle/>
-          <a:p>
-            <a:pPr indent="0" marL="0">
-              <a:buNone/>
-            </a:pPr>
-            <a:r>
-              <a:rPr lang="en-US" sz="1150" dirty="0">
-                <a:solidFill>
-                  <a:srgbClr val="8A8984"/>
-                </a:solidFill>
-                <a:latin typeface="Calibri" pitchFamily="34" charset="0"/>
-                <a:ea typeface="Calibri" pitchFamily="34" charset="-122"/>
-                <a:cs typeface="Calibri" pitchFamily="34" charset="-120"/>
-              </a:rPr>
-              <a:t>HU01–HU03 · subir video y detectar personas</a:t>
-            </a:r>
-            <a:endParaRPr lang="en-US" sz="1150" dirty="0"/>
-          </a:p>
-        </p:txBody>
-      </p:sp>
-      <p:sp>
-        <p:nvSpPr>
-          <p:cNvPr id="26" name="Text 23"/>
-          <p:cNvSpPr/>
-          <p:nvPr/>
-        </p:nvSpPr>
-        <p:spPr>
-          <a:xfrm>
-            <a:off x="5943600" y="3593592"/>
-            <a:ext cx="1097280" cy="320040"/>
-          </a:xfrm>
-          <a:prstGeom prst="rect">
-            <a:avLst/>
-          </a:prstGeom>
-          <a:noFill/>
-          <a:ln/>
-        </p:spPr>
-        <p:txBody>
-          <a:bodyPr wrap="square" lIns="0" tIns="0" rIns="0" bIns="0" rtlCol="0" anchor="t"/>
-          <a:lstStyle/>
-          <a:p>
-            <a:pPr indent="0" marL="0">
-              <a:buNone/>
-            </a:pPr>
-            <a:r>
-              <a:rPr lang="en-US" sz="1400" b="1" dirty="0">
-                <a:solidFill>
-                  <a:srgbClr val="1A1A1A"/>
-                </a:solidFill>
-                <a:latin typeface="Calibri" pitchFamily="34" charset="0"/>
-                <a:ea typeface="Calibri" pitchFamily="34" charset="-122"/>
-                <a:cs typeface="Calibri" pitchFamily="34" charset="-120"/>
-              </a:rPr>
-              <a:t>Sprint 2</a:t>
-            </a:r>
-            <a:endParaRPr lang="en-US" sz="1400" dirty="0"/>
-          </a:p>
-        </p:txBody>
-      </p:sp>
-      <p:sp>
-        <p:nvSpPr>
-          <p:cNvPr id="27" name="Shape 24"/>
-          <p:cNvSpPr/>
-          <p:nvPr/>
-        </p:nvSpPr>
-        <p:spPr>
-          <a:xfrm>
-            <a:off x="7086600" y="3639312"/>
-            <a:ext cx="3072384" cy="237744"/>
-          </a:xfrm>
-          <a:prstGeom prst="rect">
-            <a:avLst/>
+          <p:cNvPr id="25" name="Shape 22"/>
+          <p:cNvSpPr/>
+          <p:nvPr/>
+        </p:nvSpPr>
+        <p:spPr>
+          <a:xfrm>
+            <a:off x="10287000" y="2889504"/>
+            <a:ext cx="1143000" cy="292608"/>
+          </a:xfrm>
+          <a:prstGeom prst="roundRect">
+            <a:avLst>
+              <a:gd name="adj" fmla="val 50000"/>
+            </a:avLst>
           </a:prstGeom>
           <a:solidFill>
-            <a:srgbClr val="3E63DD"/>
+            <a:srgbClr val="EEF8F2"/>
           </a:solidFill>
           <a:ln w="12700">
             <a:solidFill>
-              <a:srgbClr val="3E63DD"/>
+              <a:srgbClr val="EEF8F2"/>
             </a:solidFill>
             <a:prstDash val="solid"/>
           </a:ln>
@@ -15888,13 +15812,155 @@
       </p:sp>
       <p:sp>
         <p:nvSpPr>
+          <p:cNvPr id="26" name="Text 23"/>
+          <p:cNvSpPr/>
+          <p:nvPr/>
+        </p:nvSpPr>
+        <p:spPr>
+          <a:xfrm>
+            <a:off x="10287000" y="2935224"/>
+            <a:ext cx="1143000" cy="219456"/>
+          </a:xfrm>
+          <a:prstGeom prst="rect">
+            <a:avLst/>
+          </a:prstGeom>
+          <a:noFill/>
+          <a:ln/>
+        </p:spPr>
+        <p:txBody>
+          <a:bodyPr wrap="square" lIns="0" tIns="0" rIns="0" bIns="0" rtlCol="0" anchor="t"/>
+          <a:lstStyle/>
+          <a:p>
+            <a:pPr algn="ctr" indent="0" marL="0">
+              <a:buNone/>
+            </a:pPr>
+            <a:r>
+              <a:rPr lang="en-US" sz="1100" b="1" dirty="0">
+                <a:solidFill>
+                  <a:srgbClr val="2F855A"/>
+                </a:solidFill>
+                <a:latin typeface="Calibri" pitchFamily="34" charset="0"/>
+                <a:ea typeface="Calibri" pitchFamily="34" charset="-122"/>
+                <a:cs typeface="Calibri" pitchFamily="34" charset="-120"/>
+              </a:rPr>
+              <a:t>Construido</a:t>
+            </a:r>
+            <a:endParaRPr lang="en-US" sz="1100" dirty="0"/>
+          </a:p>
+        </p:txBody>
+      </p:sp>
+      <p:sp>
+        <p:nvSpPr>
+          <p:cNvPr id="27" name="Text 24"/>
+          <p:cNvSpPr/>
+          <p:nvPr/>
+        </p:nvSpPr>
+        <p:spPr>
+          <a:xfrm>
+            <a:off x="7086600" y="3209544"/>
+            <a:ext cx="4389120" cy="274320"/>
+          </a:xfrm>
+          <a:prstGeom prst="rect">
+            <a:avLst/>
+          </a:prstGeom>
+          <a:noFill/>
+          <a:ln/>
+        </p:spPr>
+        <p:txBody>
+          <a:bodyPr wrap="square" lIns="0" tIns="0" rIns="0" bIns="0" rtlCol="0" anchor="t"/>
+          <a:lstStyle/>
+          <a:p>
+            <a:pPr indent="0" marL="0">
+              <a:buNone/>
+            </a:pPr>
+            <a:r>
+              <a:rPr lang="en-US" sz="1150" dirty="0">
+                <a:solidFill>
+                  <a:srgbClr val="8A8984"/>
+                </a:solidFill>
+                <a:latin typeface="Calibri" pitchFamily="34" charset="0"/>
+                <a:ea typeface="Calibri" pitchFamily="34" charset="-122"/>
+                <a:cs typeface="Calibri" pitchFamily="34" charset="-120"/>
+              </a:rPr>
+              <a:t>HU01–HU03 · subir video y detectar personas</a:t>
+            </a:r>
+            <a:endParaRPr lang="en-US" sz="1150" dirty="0"/>
+          </a:p>
+        </p:txBody>
+      </p:sp>
+      <p:sp>
+        <p:nvSpPr>
           <p:cNvPr id="28" name="Text 25"/>
           <p:cNvSpPr/>
           <p:nvPr/>
         </p:nvSpPr>
         <p:spPr>
           <a:xfrm>
-            <a:off x="10250424" y="3593592"/>
+            <a:off x="5943600" y="3593592"/>
+            <a:ext cx="1097280" cy="320040"/>
+          </a:xfrm>
+          <a:prstGeom prst="rect">
+            <a:avLst/>
+          </a:prstGeom>
+          <a:noFill/>
+          <a:ln/>
+        </p:spPr>
+        <p:txBody>
+          <a:bodyPr wrap="square" lIns="0" tIns="0" rIns="0" bIns="0" rtlCol="0" anchor="t"/>
+          <a:lstStyle/>
+          <a:p>
+            <a:pPr indent="0" marL="0">
+              <a:buNone/>
+            </a:pPr>
+            <a:r>
+              <a:rPr lang="en-US" sz="1400" b="1" dirty="0">
+                <a:solidFill>
+                  <a:srgbClr val="1A1A1A"/>
+                </a:solidFill>
+                <a:latin typeface="Calibri" pitchFamily="34" charset="0"/>
+                <a:ea typeface="Calibri" pitchFamily="34" charset="-122"/>
+                <a:cs typeface="Calibri" pitchFamily="34" charset="-120"/>
+              </a:rPr>
+              <a:t>Sprint 2</a:t>
+            </a:r>
+            <a:endParaRPr lang="en-US" sz="1400" dirty="0"/>
+          </a:p>
+        </p:txBody>
+      </p:sp>
+      <p:sp>
+        <p:nvSpPr>
+          <p:cNvPr id="29" name="Shape 26"/>
+          <p:cNvSpPr/>
+          <p:nvPr/>
+        </p:nvSpPr>
+        <p:spPr>
+          <a:xfrm>
+            <a:off x="7086600" y="3639312"/>
+            <a:ext cx="2633472" cy="237744"/>
+          </a:xfrm>
+          <a:prstGeom prst="rect">
+            <a:avLst/>
+          </a:prstGeom>
+          <a:solidFill>
+            <a:srgbClr val="2F855A"/>
+          </a:solidFill>
+          <a:ln w="12700">
+            <a:solidFill>
+              <a:srgbClr val="2F855A"/>
+            </a:solidFill>
+            <a:prstDash val="solid"/>
+          </a:ln>
+        </p:spPr>
+      </p:sp>
+      <p:sp>
+        <p:nvSpPr>
+          <p:cNvPr id="30" name="Text 27"/>
+          <p:cNvSpPr/>
+          <p:nvPr/>
+        </p:nvSpPr>
+        <p:spPr>
+          <a:xfrm>
+            <a:off x="9811512" y="3593592"/>
             <a:ext cx="457200" cy="320040"/>
           </a:xfrm>
           <a:prstGeom prst="rect">
@@ -15927,7 +15993,73 @@
       </p:sp>
       <p:sp>
         <p:nvSpPr>
-          <p:cNvPr id="29" name="Text 26"/>
+          <p:cNvPr id="31" name="Shape 28"/>
+          <p:cNvSpPr/>
+          <p:nvPr/>
+        </p:nvSpPr>
+        <p:spPr>
+          <a:xfrm>
+            <a:off x="10287000" y="3602736"/>
+            <a:ext cx="1143000" cy="292608"/>
+          </a:xfrm>
+          <a:prstGeom prst="roundRect">
+            <a:avLst>
+              <a:gd name="adj" fmla="val 50000"/>
+            </a:avLst>
+          </a:prstGeom>
+          <a:solidFill>
+            <a:srgbClr val="EEF8F2"/>
+          </a:solidFill>
+          <a:ln w="12700">
+            <a:solidFill>
+              <a:srgbClr val="EEF8F2"/>
+            </a:solidFill>
+            <a:prstDash val="solid"/>
+          </a:ln>
+        </p:spPr>
+      </p:sp>
+      <p:sp>
+        <p:nvSpPr>
+          <p:cNvPr id="32" name="Text 29"/>
+          <p:cNvSpPr/>
+          <p:nvPr/>
+        </p:nvSpPr>
+        <p:spPr>
+          <a:xfrm>
+            <a:off x="10287000" y="3648456"/>
+            <a:ext cx="1143000" cy="219456"/>
+          </a:xfrm>
+          <a:prstGeom prst="rect">
+            <a:avLst/>
+          </a:prstGeom>
+          <a:noFill/>
+          <a:ln/>
+        </p:spPr>
+        <p:txBody>
+          <a:bodyPr wrap="square" lIns="0" tIns="0" rIns="0" bIns="0" rtlCol="0" anchor="t"/>
+          <a:lstStyle/>
+          <a:p>
+            <a:pPr algn="ctr" indent="0" marL="0">
+              <a:buNone/>
+            </a:pPr>
+            <a:r>
+              <a:rPr lang="en-US" sz="1100" b="1" dirty="0">
+                <a:solidFill>
+                  <a:srgbClr val="2F855A"/>
+                </a:solidFill>
+                <a:latin typeface="Calibri" pitchFamily="34" charset="0"/>
+                <a:ea typeface="Calibri" pitchFamily="34" charset="-122"/>
+                <a:cs typeface="Calibri" pitchFamily="34" charset="-120"/>
+              </a:rPr>
+              <a:t>Construido</a:t>
+            </a:r>
+            <a:endParaRPr lang="en-US" sz="1100" dirty="0"/>
+          </a:p>
+        </p:txBody>
+      </p:sp>
+      <p:sp>
+        <p:nvSpPr>
+          <p:cNvPr id="33" name="Text 30"/>
           <p:cNvSpPr/>
           <p:nvPr/>
         </p:nvSpPr>
@@ -15966,7 +16098,7 @@
       </p:sp>
       <p:sp>
         <p:nvSpPr>
-          <p:cNvPr id="30" name="Text 27"/>
+          <p:cNvPr id="34" name="Text 31"/>
           <p:cNvSpPr/>
           <p:nvPr/>
         </p:nvSpPr>
@@ -16005,14 +16137,14 @@
       </p:sp>
       <p:sp>
         <p:nvSpPr>
-          <p:cNvPr id="31" name="Shape 28"/>
+          <p:cNvPr id="35" name="Shape 32"/>
           <p:cNvSpPr/>
           <p:nvPr/>
         </p:nvSpPr>
         <p:spPr>
           <a:xfrm>
             <a:off x="7086600" y="4352544"/>
-            <a:ext cx="3072384" cy="237744"/>
+            <a:ext cx="2633472" cy="237744"/>
           </a:xfrm>
           <a:prstGeom prst="rect">
             <a:avLst/>
@@ -16030,13 +16162,13 @@
       </p:sp>
       <p:sp>
         <p:nvSpPr>
-          <p:cNvPr id="32" name="Text 29"/>
-          <p:cNvSpPr/>
-          <p:nvPr/>
-        </p:nvSpPr>
-        <p:spPr>
-          <a:xfrm>
-            <a:off x="10250424" y="4306824"/>
+          <p:cNvPr id="36" name="Text 33"/>
+          <p:cNvSpPr/>
+          <p:nvPr/>
+        </p:nvSpPr>
+        <p:spPr>
+          <a:xfrm>
+            <a:off x="9811512" y="4306824"/>
             <a:ext cx="457200" cy="320040"/>
           </a:xfrm>
           <a:prstGeom prst="rect">
@@ -16069,7 +16201,7 @@
       </p:sp>
       <p:sp>
         <p:nvSpPr>
-          <p:cNvPr id="33" name="Text 30"/>
+          <p:cNvPr id="37" name="Text 34"/>
           <p:cNvSpPr/>
           <p:nvPr/>
         </p:nvSpPr>
@@ -16108,7 +16240,7 @@
       </p:sp>
       <p:sp>
         <p:nvSpPr>
-          <p:cNvPr id="34" name="Text 31"/>
+          <p:cNvPr id="38" name="Text 35"/>
           <p:cNvSpPr/>
           <p:nvPr/>
         </p:nvSpPr>
@@ -16147,14 +16279,14 @@
       </p:sp>
       <p:sp>
         <p:nvSpPr>
-          <p:cNvPr id="35" name="Shape 32"/>
+          <p:cNvPr id="39" name="Shape 36"/>
           <p:cNvSpPr/>
           <p:nvPr/>
         </p:nvSpPr>
         <p:spPr>
           <a:xfrm>
             <a:off x="7086600" y="5065776"/>
-            <a:ext cx="3072384" cy="237744"/>
+            <a:ext cx="2633472" cy="237744"/>
           </a:xfrm>
           <a:prstGeom prst="rect">
             <a:avLst/>
@@ -16172,13 +16304,13 @@
       </p:sp>
       <p:sp>
         <p:nvSpPr>
-          <p:cNvPr id="36" name="Text 33"/>
-          <p:cNvSpPr/>
-          <p:nvPr/>
-        </p:nvSpPr>
-        <p:spPr>
-          <a:xfrm>
-            <a:off x="10250424" y="5020056"/>
+          <p:cNvPr id="40" name="Text 37"/>
+          <p:cNvSpPr/>
+          <p:nvPr/>
+        </p:nvSpPr>
+        <p:spPr>
+          <a:xfrm>
+            <a:off x="9811512" y="5020056"/>
             <a:ext cx="457200" cy="320040"/>
           </a:xfrm>
           <a:prstGeom prst="rect">
@@ -16211,7 +16343,7 @@
       </p:sp>
       <p:sp>
         <p:nvSpPr>
-          <p:cNvPr id="37" name="Text 34"/>
+          <p:cNvPr id="41" name="Text 38"/>
           <p:cNvSpPr/>
           <p:nvPr/>
         </p:nvSpPr>
@@ -16250,7 +16382,7 @@
       </p:sp>
       <p:sp>
         <p:nvSpPr>
-          <p:cNvPr id="38" name="Text 35"/>
+          <p:cNvPr id="42" name="Text 39"/>
           <p:cNvSpPr/>
           <p:nvPr/>
         </p:nvSpPr>
@@ -16281,7 +16413,7 @@
                 <a:ea typeface="Calibri" pitchFamily="34" charset="-122"/>
                 <a:cs typeface="Calibri" pitchFamily="34" charset="-120"/>
               </a:rPr>
-              <a:t>Fuente del método: SCRUMstudy (2022), pp. 76–78 y 166–172.</a:t>
+              <a:t>Fuente del método: SCRUMstudy (2022), pp. 76–78 y 166–172. Estado al 20/10/2026; la aceptación del PO es en la revisión del sprint.</a:t>
             </a:r>
             <a:endParaRPr lang="en-US" sz="1000" dirty="0"/>
           </a:p>
@@ -16929,7 +17061,7 @@
                 <a:ea typeface="Calibri" pitchFamily="34" charset="-122"/>
                 <a:cs typeface="Calibri" pitchFamily="34" charset="-120"/>
               </a:rPr>
-              <a:t>Scrumboard del Sprint 1: por hacer, en progreso, en prueba y terminada.</a:t>
+              <a:t>Scrumboard del Sprint 1 como se planificó en la semana 5. Su estado de hoy: lámina 28.</a:t>
             </a:r>
             <a:endParaRPr lang="en-US" sz="1200" dirty="0"/>
           </a:p>
@@ -21247,7 +21379,7 @@
                 <a:ea typeface="Calibri Light" pitchFamily="34" charset="-122"/>
                 <a:cs typeface="Calibri Light" pitchFamily="34" charset="-120"/>
               </a:rPr>
-              <a:t>El tablero, hoy</a:t>
+              <a:t>El Scrumboard, hoy</a:t>
             </a:r>
             <a:endParaRPr lang="en-US" sz="3400" dirty="0"/>
           </a:p>
@@ -21379,7 +21511,7 @@
         <p:spPr>
           <a:xfrm>
             <a:off x="731520" y="1783080"/>
-            <a:ext cx="1828800" cy="274320"/>
+            <a:ext cx="2011680" cy="274320"/>
           </a:xfrm>
           <a:prstGeom prst="rect">
             <a:avLst/>
@@ -21397,13 +21529,922 @@
             <a:r>
               <a:rPr lang="en-US" sz="1100" b="1" spc="100" kern="0" dirty="0">
                 <a:solidFill>
+                  <a:srgbClr val="8A8984"/>
+                </a:solidFill>
+                <a:latin typeface="Calibri" pitchFamily="34" charset="0"/>
+                <a:ea typeface="Calibri" pitchFamily="34" charset="-122"/>
+                <a:cs typeface="Calibri" pitchFamily="34" charset="-120"/>
+              </a:rPr>
+              <a:t>POR HACER</a:t>
+            </a:r>
+            <a:endParaRPr lang="en-US" sz="1100" dirty="0"/>
+          </a:p>
+        </p:txBody>
+      </p:sp>
+      <p:sp>
+        <p:nvSpPr>
+          <p:cNvPr id="9" name="Text 6"/>
+          <p:cNvSpPr/>
+          <p:nvPr/>
+        </p:nvSpPr>
+        <p:spPr>
+          <a:xfrm>
+            <a:off x="2560320" y="1783080"/>
+            <a:ext cx="502920" cy="274320"/>
+          </a:xfrm>
+          <a:prstGeom prst="rect">
+            <a:avLst/>
+          </a:prstGeom>
+          <a:noFill/>
+          <a:ln/>
+        </p:spPr>
+        <p:txBody>
+          <a:bodyPr wrap="square" lIns="0" tIns="0" rIns="0" bIns="0" rtlCol="0" anchor="t"/>
+          <a:lstStyle/>
+          <a:p>
+            <a:pPr algn="r" indent="0" marL="0">
+              <a:buNone/>
+            </a:pPr>
+            <a:r>
+              <a:rPr lang="en-US" sz="1100" dirty="0">
+                <a:solidFill>
+                  <a:srgbClr val="8A8984"/>
+                </a:solidFill>
+                <a:latin typeface="Calibri" pitchFamily="34" charset="0"/>
+                <a:ea typeface="Calibri" pitchFamily="34" charset="-122"/>
+                <a:cs typeface="Calibri" pitchFamily="34" charset="-120"/>
+              </a:rPr>
+              <a:t>16 pts</a:t>
+            </a:r>
+            <a:endParaRPr lang="en-US" sz="1100" dirty="0"/>
+          </a:p>
+        </p:txBody>
+      </p:sp>
+      <p:sp>
+        <p:nvSpPr>
+          <p:cNvPr id="10" name="Shape 7"/>
+          <p:cNvSpPr/>
+          <p:nvPr/>
+        </p:nvSpPr>
+        <p:spPr>
+          <a:xfrm>
+            <a:off x="731520" y="2148840"/>
+            <a:ext cx="2331720" cy="475488"/>
+          </a:xfrm>
+          <a:prstGeom prst="roundRect">
+            <a:avLst>
+              <a:gd name="adj" fmla="val 15385"/>
+            </a:avLst>
+          </a:prstGeom>
+          <a:solidFill>
+            <a:srgbClr val="FFFFFF"/>
+          </a:solidFill>
+          <a:ln w="9525">
+            <a:solidFill>
+              <a:srgbClr val="E7E5E4"/>
+            </a:solidFill>
+            <a:prstDash val="solid"/>
+          </a:ln>
+        </p:spPr>
+      </p:sp>
+      <p:sp>
+        <p:nvSpPr>
+          <p:cNvPr id="11" name="Text 8"/>
+          <p:cNvSpPr/>
+          <p:nvPr/>
+        </p:nvSpPr>
+        <p:spPr>
+          <a:xfrm>
+            <a:off x="868680" y="2276856"/>
+            <a:ext cx="1920240" cy="274320"/>
+          </a:xfrm>
+          <a:prstGeom prst="rect">
+            <a:avLst/>
+          </a:prstGeom>
+          <a:noFill/>
+          <a:ln/>
+        </p:spPr>
+        <p:txBody>
+          <a:bodyPr wrap="square" lIns="0" tIns="0" rIns="0" bIns="0" rtlCol="0" anchor="t"/>
+          <a:lstStyle/>
+          <a:p>
+            <a:pPr indent="0" marL="0">
+              <a:buNone/>
+            </a:pPr>
+            <a:r>
+              <a:rPr lang="en-US" sz="1200" b="1" dirty="0">
+                <a:solidFill>
+                  <a:srgbClr val="1A1A1A"/>
+                </a:solidFill>
+                <a:latin typeface="Calibri" pitchFamily="34" charset="0"/>
+                <a:ea typeface="Calibri" pitchFamily="34" charset="-122"/>
+                <a:cs typeface="Calibri" pitchFamily="34" charset="-120"/>
+              </a:rPr>
+              <a:t>HU07  </a:t>
+            </a:r>
+            <a:pPr indent="0" marL="0">
+              <a:buNone/>
+            </a:pPr>
+            <a:r>
+              <a:rPr lang="en-US" sz="1200" dirty="0">
+                <a:solidFill>
+                  <a:srgbClr val="1A1A1A"/>
+                </a:solidFill>
+                <a:latin typeface="Calibri" pitchFamily="34" charset="0"/>
+                <a:ea typeface="Calibri" pitchFamily="34" charset="-122"/>
+                <a:cs typeface="Calibri" pitchFamily="34" charset="-120"/>
+              </a:rPr>
+              <a:t>Procesar con ConvLSTM</a:t>
+            </a:r>
+            <a:endParaRPr lang="en-US" sz="1200" dirty="0"/>
+          </a:p>
+        </p:txBody>
+      </p:sp>
+      <p:sp>
+        <p:nvSpPr>
+          <p:cNvPr id="12" name="Text 9"/>
+          <p:cNvSpPr/>
+          <p:nvPr/>
+        </p:nvSpPr>
+        <p:spPr>
+          <a:xfrm>
+            <a:off x="2697480" y="2276856"/>
+            <a:ext cx="256032" cy="274320"/>
+          </a:xfrm>
+          <a:prstGeom prst="rect">
+            <a:avLst/>
+          </a:prstGeom>
+          <a:noFill/>
+          <a:ln/>
+        </p:spPr>
+        <p:txBody>
+          <a:bodyPr wrap="square" lIns="0" tIns="0" rIns="0" bIns="0" rtlCol="0" anchor="t"/>
+          <a:lstStyle/>
+          <a:p>
+            <a:pPr algn="r" indent="0" marL="0">
+              <a:buNone/>
+            </a:pPr>
+            <a:r>
+              <a:rPr lang="en-US" sz="1200" dirty="0">
+                <a:solidFill>
+                  <a:srgbClr val="8A8984"/>
+                </a:solidFill>
+                <a:latin typeface="Calibri" pitchFamily="34" charset="0"/>
+                <a:ea typeface="Calibri" pitchFamily="34" charset="-122"/>
+                <a:cs typeface="Calibri" pitchFamily="34" charset="-120"/>
+              </a:rPr>
+              <a:t>5</a:t>
+            </a:r>
+            <a:endParaRPr lang="en-US" sz="1200" dirty="0"/>
+          </a:p>
+        </p:txBody>
+      </p:sp>
+      <p:sp>
+        <p:nvSpPr>
+          <p:cNvPr id="13" name="Shape 10"/>
+          <p:cNvSpPr/>
+          <p:nvPr/>
+        </p:nvSpPr>
+        <p:spPr>
+          <a:xfrm>
+            <a:off x="731520" y="2715768"/>
+            <a:ext cx="2331720" cy="475488"/>
+          </a:xfrm>
+          <a:prstGeom prst="roundRect">
+            <a:avLst>
+              <a:gd name="adj" fmla="val 15385"/>
+            </a:avLst>
+          </a:prstGeom>
+          <a:solidFill>
+            <a:srgbClr val="FFFFFF"/>
+          </a:solidFill>
+          <a:ln w="9525">
+            <a:solidFill>
+              <a:srgbClr val="E7E5E4"/>
+            </a:solidFill>
+            <a:prstDash val="solid"/>
+          </a:ln>
+        </p:spPr>
+      </p:sp>
+      <p:sp>
+        <p:nvSpPr>
+          <p:cNvPr id="14" name="Text 11"/>
+          <p:cNvSpPr/>
+          <p:nvPr/>
+        </p:nvSpPr>
+        <p:spPr>
+          <a:xfrm>
+            <a:off x="868680" y="2843784"/>
+            <a:ext cx="1920240" cy="274320"/>
+          </a:xfrm>
+          <a:prstGeom prst="rect">
+            <a:avLst/>
+          </a:prstGeom>
+          <a:noFill/>
+          <a:ln/>
+        </p:spPr>
+        <p:txBody>
+          <a:bodyPr wrap="square" lIns="0" tIns="0" rIns="0" bIns="0" rtlCol="0" anchor="t"/>
+          <a:lstStyle/>
+          <a:p>
+            <a:pPr indent="0" marL="0">
+              <a:buNone/>
+            </a:pPr>
+            <a:r>
+              <a:rPr lang="en-US" sz="1200" b="1" dirty="0">
+                <a:solidFill>
+                  <a:srgbClr val="1A1A1A"/>
+                </a:solidFill>
+                <a:latin typeface="Calibri" pitchFamily="34" charset="0"/>
+                <a:ea typeface="Calibri" pitchFamily="34" charset="-122"/>
+                <a:cs typeface="Calibri" pitchFamily="34" charset="-120"/>
+              </a:rPr>
+              <a:t>HU08  </a:t>
+            </a:r>
+            <a:pPr indent="0" marL="0">
+              <a:buNone/>
+            </a:pPr>
+            <a:r>
+              <a:rPr lang="en-US" sz="1200" dirty="0">
+                <a:solidFill>
+                  <a:srgbClr val="1A1A1A"/>
+                </a:solidFill>
+                <a:latin typeface="Calibri" pitchFamily="34" charset="0"/>
+                <a:ea typeface="Calibri" pitchFamily="34" charset="-122"/>
+                <a:cs typeface="Calibri" pitchFamily="34" charset="-120"/>
+              </a:rPr>
+              <a:t>Clasificar la conducta</a:t>
+            </a:r>
+            <a:endParaRPr lang="en-US" sz="1200" dirty="0"/>
+          </a:p>
+        </p:txBody>
+      </p:sp>
+      <p:sp>
+        <p:nvSpPr>
+          <p:cNvPr id="15" name="Text 12"/>
+          <p:cNvSpPr/>
+          <p:nvPr/>
+        </p:nvSpPr>
+        <p:spPr>
+          <a:xfrm>
+            <a:off x="2697480" y="2843784"/>
+            <a:ext cx="256032" cy="274320"/>
+          </a:xfrm>
+          <a:prstGeom prst="rect">
+            <a:avLst/>
+          </a:prstGeom>
+          <a:noFill/>
+          <a:ln/>
+        </p:spPr>
+        <p:txBody>
+          <a:bodyPr wrap="square" lIns="0" tIns="0" rIns="0" bIns="0" rtlCol="0" anchor="t"/>
+          <a:lstStyle/>
+          <a:p>
+            <a:pPr algn="r" indent="0" marL="0">
+              <a:buNone/>
+            </a:pPr>
+            <a:r>
+              <a:rPr lang="en-US" sz="1200" dirty="0">
+                <a:solidFill>
+                  <a:srgbClr val="8A8984"/>
+                </a:solidFill>
+                <a:latin typeface="Calibri" pitchFamily="34" charset="0"/>
+                <a:ea typeface="Calibri" pitchFamily="34" charset="-122"/>
+                <a:cs typeface="Calibri" pitchFamily="34" charset="-120"/>
+              </a:rPr>
+              <a:t>3</a:t>
+            </a:r>
+            <a:endParaRPr lang="en-US" sz="1200" dirty="0"/>
+          </a:p>
+        </p:txBody>
+      </p:sp>
+      <p:sp>
+        <p:nvSpPr>
+          <p:cNvPr id="16" name="Shape 13"/>
+          <p:cNvSpPr/>
+          <p:nvPr/>
+        </p:nvSpPr>
+        <p:spPr>
+          <a:xfrm>
+            <a:off x="731520" y="3282696"/>
+            <a:ext cx="2331720" cy="475488"/>
+          </a:xfrm>
+          <a:prstGeom prst="roundRect">
+            <a:avLst>
+              <a:gd name="adj" fmla="val 15385"/>
+            </a:avLst>
+          </a:prstGeom>
+          <a:solidFill>
+            <a:srgbClr val="FFFFFF"/>
+          </a:solidFill>
+          <a:ln w="9525">
+            <a:solidFill>
+              <a:srgbClr val="E7E5E4"/>
+            </a:solidFill>
+            <a:prstDash val="solid"/>
+          </a:ln>
+        </p:spPr>
+      </p:sp>
+      <p:sp>
+        <p:nvSpPr>
+          <p:cNvPr id="17" name="Text 14"/>
+          <p:cNvSpPr/>
+          <p:nvPr/>
+        </p:nvSpPr>
+        <p:spPr>
+          <a:xfrm>
+            <a:off x="868680" y="3410712"/>
+            <a:ext cx="1920240" cy="274320"/>
+          </a:xfrm>
+          <a:prstGeom prst="rect">
+            <a:avLst/>
+          </a:prstGeom>
+          <a:noFill/>
+          <a:ln/>
+        </p:spPr>
+        <p:txBody>
+          <a:bodyPr wrap="square" lIns="0" tIns="0" rIns="0" bIns="0" rtlCol="0" anchor="t"/>
+          <a:lstStyle/>
+          <a:p>
+            <a:pPr indent="0" marL="0">
+              <a:buNone/>
+            </a:pPr>
+            <a:r>
+              <a:rPr lang="en-US" sz="1200" b="1" dirty="0">
+                <a:solidFill>
+                  <a:srgbClr val="1A1A1A"/>
+                </a:solidFill>
+                <a:latin typeface="Calibri" pitchFamily="34" charset="0"/>
+                <a:ea typeface="Calibri" pitchFamily="34" charset="-122"/>
+                <a:cs typeface="Calibri" pitchFamily="34" charset="-120"/>
+              </a:rPr>
+              <a:t>HU09  </a:t>
+            </a:r>
+            <a:pPr indent="0" marL="0">
+              <a:buNone/>
+            </a:pPr>
+            <a:r>
+              <a:rPr lang="en-US" sz="1200" dirty="0">
+                <a:solidFill>
+                  <a:srgbClr val="1A1A1A"/>
+                </a:solidFill>
+                <a:latin typeface="Calibri" pitchFamily="34" charset="0"/>
+                <a:ea typeface="Calibri" pitchFamily="34" charset="-122"/>
+                <a:cs typeface="Calibri" pitchFamily="34" charset="-120"/>
+              </a:rPr>
+              <a:t>Recuadro de riesgo</a:t>
+            </a:r>
+            <a:endParaRPr lang="en-US" sz="1200" dirty="0"/>
+          </a:p>
+        </p:txBody>
+      </p:sp>
+      <p:sp>
+        <p:nvSpPr>
+          <p:cNvPr id="18" name="Text 15"/>
+          <p:cNvSpPr/>
+          <p:nvPr/>
+        </p:nvSpPr>
+        <p:spPr>
+          <a:xfrm>
+            <a:off x="2697480" y="3410712"/>
+            <a:ext cx="256032" cy="274320"/>
+          </a:xfrm>
+          <a:prstGeom prst="rect">
+            <a:avLst/>
+          </a:prstGeom>
+          <a:noFill/>
+          <a:ln/>
+        </p:spPr>
+        <p:txBody>
+          <a:bodyPr wrap="square" lIns="0" tIns="0" rIns="0" bIns="0" rtlCol="0" anchor="t"/>
+          <a:lstStyle/>
+          <a:p>
+            <a:pPr algn="r" indent="0" marL="0">
+              <a:buNone/>
+            </a:pPr>
+            <a:r>
+              <a:rPr lang="en-US" sz="1200" dirty="0">
+                <a:solidFill>
+                  <a:srgbClr val="8A8984"/>
+                </a:solidFill>
+                <a:latin typeface="Calibri" pitchFamily="34" charset="0"/>
+                <a:ea typeface="Calibri" pitchFamily="34" charset="-122"/>
+                <a:cs typeface="Calibri" pitchFamily="34" charset="-120"/>
+              </a:rPr>
+              <a:t>4</a:t>
+            </a:r>
+            <a:endParaRPr lang="en-US" sz="1200" dirty="0"/>
+          </a:p>
+        </p:txBody>
+      </p:sp>
+      <p:sp>
+        <p:nvSpPr>
+          <p:cNvPr id="19" name="Shape 16"/>
+          <p:cNvSpPr/>
+          <p:nvPr/>
+        </p:nvSpPr>
+        <p:spPr>
+          <a:xfrm>
+            <a:off x="731520" y="3849624"/>
+            <a:ext cx="2331720" cy="475488"/>
+          </a:xfrm>
+          <a:prstGeom prst="roundRect">
+            <a:avLst>
+              <a:gd name="adj" fmla="val 15385"/>
+            </a:avLst>
+          </a:prstGeom>
+          <a:solidFill>
+            <a:srgbClr val="FFFFFF"/>
+          </a:solidFill>
+          <a:ln w="9525">
+            <a:solidFill>
+              <a:srgbClr val="E7E5E4"/>
+            </a:solidFill>
+            <a:prstDash val="solid"/>
+          </a:ln>
+        </p:spPr>
+      </p:sp>
+      <p:sp>
+        <p:nvSpPr>
+          <p:cNvPr id="20" name="Text 17"/>
+          <p:cNvSpPr/>
+          <p:nvPr/>
+        </p:nvSpPr>
+        <p:spPr>
+          <a:xfrm>
+            <a:off x="868680" y="3977640"/>
+            <a:ext cx="1920240" cy="274320"/>
+          </a:xfrm>
+          <a:prstGeom prst="rect">
+            <a:avLst/>
+          </a:prstGeom>
+          <a:noFill/>
+          <a:ln/>
+        </p:spPr>
+        <p:txBody>
+          <a:bodyPr wrap="square" lIns="0" tIns="0" rIns="0" bIns="0" rtlCol="0" anchor="t"/>
+          <a:lstStyle/>
+          <a:p>
+            <a:pPr indent="0" marL="0">
+              <a:buNone/>
+            </a:pPr>
+            <a:r>
+              <a:rPr lang="en-US" sz="1200" b="1" dirty="0">
+                <a:solidFill>
+                  <a:srgbClr val="1A1A1A"/>
+                </a:solidFill>
+                <a:latin typeface="Calibri" pitchFamily="34" charset="0"/>
+                <a:ea typeface="Calibri" pitchFamily="34" charset="-122"/>
+                <a:cs typeface="Calibri" pitchFamily="34" charset="-120"/>
+              </a:rPr>
+              <a:t>HU10  </a:t>
+            </a:r>
+            <a:pPr indent="0" marL="0">
+              <a:buNone/>
+            </a:pPr>
+            <a:r>
+              <a:rPr lang="en-US" sz="1200" dirty="0">
+                <a:solidFill>
+                  <a:srgbClr val="1A1A1A"/>
+                </a:solidFill>
+                <a:latin typeface="Calibri" pitchFamily="34" charset="0"/>
+                <a:ea typeface="Calibri" pitchFamily="34" charset="-122"/>
+                <a:cs typeface="Calibri" pitchFamily="34" charset="-120"/>
+              </a:rPr>
+              <a:t>Alerta de riesgo</a:t>
+            </a:r>
+            <a:endParaRPr lang="en-US" sz="1200" dirty="0"/>
+          </a:p>
+        </p:txBody>
+      </p:sp>
+      <p:sp>
+        <p:nvSpPr>
+          <p:cNvPr id="21" name="Text 18"/>
+          <p:cNvSpPr/>
+          <p:nvPr/>
+        </p:nvSpPr>
+        <p:spPr>
+          <a:xfrm>
+            <a:off x="2697480" y="3977640"/>
+            <a:ext cx="256032" cy="274320"/>
+          </a:xfrm>
+          <a:prstGeom prst="rect">
+            <a:avLst/>
+          </a:prstGeom>
+          <a:noFill/>
+          <a:ln/>
+        </p:spPr>
+        <p:txBody>
+          <a:bodyPr wrap="square" lIns="0" tIns="0" rIns="0" bIns="0" rtlCol="0" anchor="t"/>
+          <a:lstStyle/>
+          <a:p>
+            <a:pPr algn="r" indent="0" marL="0">
+              <a:buNone/>
+            </a:pPr>
+            <a:r>
+              <a:rPr lang="en-US" sz="1200" dirty="0">
+                <a:solidFill>
+                  <a:srgbClr val="8A8984"/>
+                </a:solidFill>
+                <a:latin typeface="Calibri" pitchFamily="34" charset="0"/>
+                <a:ea typeface="Calibri" pitchFamily="34" charset="-122"/>
+                <a:cs typeface="Calibri" pitchFamily="34" charset="-120"/>
+              </a:rPr>
+              <a:t>2</a:t>
+            </a:r>
+            <a:endParaRPr lang="en-US" sz="1200" dirty="0"/>
+          </a:p>
+        </p:txBody>
+      </p:sp>
+      <p:sp>
+        <p:nvSpPr>
+          <p:cNvPr id="22" name="Shape 19"/>
+          <p:cNvSpPr/>
+          <p:nvPr/>
+        </p:nvSpPr>
+        <p:spPr>
+          <a:xfrm>
+            <a:off x="731520" y="4416552"/>
+            <a:ext cx="2331720" cy="475488"/>
+          </a:xfrm>
+          <a:prstGeom prst="roundRect">
+            <a:avLst>
+              <a:gd name="adj" fmla="val 15385"/>
+            </a:avLst>
+          </a:prstGeom>
+          <a:solidFill>
+            <a:srgbClr val="FFFFFF"/>
+          </a:solidFill>
+          <a:ln w="9525">
+            <a:solidFill>
+              <a:srgbClr val="E7E5E4"/>
+            </a:solidFill>
+            <a:prstDash val="solid"/>
+          </a:ln>
+        </p:spPr>
+      </p:sp>
+      <p:sp>
+        <p:nvSpPr>
+          <p:cNvPr id="23" name="Text 20"/>
+          <p:cNvSpPr/>
+          <p:nvPr/>
+        </p:nvSpPr>
+        <p:spPr>
+          <a:xfrm>
+            <a:off x="868680" y="4544568"/>
+            <a:ext cx="1920240" cy="274320"/>
+          </a:xfrm>
+          <a:prstGeom prst="rect">
+            <a:avLst/>
+          </a:prstGeom>
+          <a:noFill/>
+          <a:ln/>
+        </p:spPr>
+        <p:txBody>
+          <a:bodyPr wrap="square" lIns="0" tIns="0" rIns="0" bIns="0" rtlCol="0" anchor="t"/>
+          <a:lstStyle/>
+          <a:p>
+            <a:pPr indent="0" marL="0">
+              <a:buNone/>
+            </a:pPr>
+            <a:r>
+              <a:rPr lang="en-US" sz="1200" b="1" dirty="0">
+                <a:solidFill>
+                  <a:srgbClr val="1A1A1A"/>
+                </a:solidFill>
+                <a:latin typeface="Calibri" pitchFamily="34" charset="0"/>
+                <a:ea typeface="Calibri" pitchFamily="34" charset="-122"/>
+                <a:cs typeface="Calibri" pitchFamily="34" charset="-120"/>
+              </a:rPr>
+              <a:t>HU12  </a:t>
+            </a:r>
+            <a:pPr indent="0" marL="0">
+              <a:buNone/>
+            </a:pPr>
+            <a:r>
+              <a:rPr lang="en-US" sz="1200" dirty="0">
+                <a:solidFill>
+                  <a:srgbClr val="1A1A1A"/>
+                </a:solidFill>
+                <a:latin typeface="Calibri" pitchFamily="34" charset="0"/>
+                <a:ea typeface="Calibri" pitchFamily="34" charset="-122"/>
+                <a:cs typeface="Calibri" pitchFamily="34" charset="-120"/>
+              </a:rPr>
+              <a:t>Log de tiempos</a:t>
+            </a:r>
+            <a:endParaRPr lang="en-US" sz="1200" dirty="0"/>
+          </a:p>
+        </p:txBody>
+      </p:sp>
+      <p:sp>
+        <p:nvSpPr>
+          <p:cNvPr id="24" name="Text 21"/>
+          <p:cNvSpPr/>
+          <p:nvPr/>
+        </p:nvSpPr>
+        <p:spPr>
+          <a:xfrm>
+            <a:off x="2697480" y="4544568"/>
+            <a:ext cx="256032" cy="274320"/>
+          </a:xfrm>
+          <a:prstGeom prst="rect">
+            <a:avLst/>
+          </a:prstGeom>
+          <a:noFill/>
+          <a:ln/>
+        </p:spPr>
+        <p:txBody>
+          <a:bodyPr wrap="square" lIns="0" tIns="0" rIns="0" bIns="0" rtlCol="0" anchor="t"/>
+          <a:lstStyle/>
+          <a:p>
+            <a:pPr algn="r" indent="0" marL="0">
+              <a:buNone/>
+            </a:pPr>
+            <a:r>
+              <a:rPr lang="en-US" sz="1200" dirty="0">
+                <a:solidFill>
+                  <a:srgbClr val="8A8984"/>
+                </a:solidFill>
+                <a:latin typeface="Calibri" pitchFamily="34" charset="0"/>
+                <a:ea typeface="Calibri" pitchFamily="34" charset="-122"/>
+                <a:cs typeface="Calibri" pitchFamily="34" charset="-120"/>
+              </a:rPr>
+              <a:t>2</a:t>
+            </a:r>
+            <a:endParaRPr lang="en-US" sz="1200" dirty="0"/>
+          </a:p>
+        </p:txBody>
+      </p:sp>
+      <p:sp>
+        <p:nvSpPr>
+          <p:cNvPr id="25" name="Text 22"/>
+          <p:cNvSpPr/>
+          <p:nvPr/>
+        </p:nvSpPr>
+        <p:spPr>
+          <a:xfrm>
+            <a:off x="3200400" y="1783080"/>
+            <a:ext cx="2011680" cy="274320"/>
+          </a:xfrm>
+          <a:prstGeom prst="rect">
+            <a:avLst/>
+          </a:prstGeom>
+          <a:noFill/>
+          <a:ln/>
+        </p:spPr>
+        <p:txBody>
+          <a:bodyPr wrap="square" lIns="0" tIns="0" rIns="0" bIns="0" rtlCol="0" anchor="t"/>
+          <a:lstStyle/>
+          <a:p>
+            <a:pPr indent="0" marL="0">
+              <a:buNone/>
+            </a:pPr>
+            <a:r>
+              <a:rPr lang="en-US" sz="1100" b="1" spc="100" kern="0" dirty="0">
+                <a:solidFill>
+                  <a:srgbClr val="C2410C"/>
+                </a:solidFill>
+                <a:latin typeface="Calibri" pitchFamily="34" charset="0"/>
+                <a:ea typeface="Calibri" pitchFamily="34" charset="-122"/>
+                <a:cs typeface="Calibri" pitchFamily="34" charset="-120"/>
+              </a:rPr>
+              <a:t>EN PROGRESO</a:t>
+            </a:r>
+            <a:endParaRPr lang="en-US" sz="1100" dirty="0"/>
+          </a:p>
+        </p:txBody>
+      </p:sp>
+      <p:sp>
+        <p:nvSpPr>
+          <p:cNvPr id="26" name="Text 23"/>
+          <p:cNvSpPr/>
+          <p:nvPr/>
+        </p:nvSpPr>
+        <p:spPr>
+          <a:xfrm>
+            <a:off x="5029200" y="1783080"/>
+            <a:ext cx="502920" cy="274320"/>
+          </a:xfrm>
+          <a:prstGeom prst="rect">
+            <a:avLst/>
+          </a:prstGeom>
+          <a:noFill/>
+          <a:ln/>
+        </p:spPr>
+        <p:txBody>
+          <a:bodyPr wrap="square" lIns="0" tIns="0" rIns="0" bIns="0" rtlCol="0" anchor="t"/>
+          <a:lstStyle/>
+          <a:p>
+            <a:pPr algn="r" indent="0" marL="0">
+              <a:buNone/>
+            </a:pPr>
+            <a:r>
+              <a:rPr lang="en-US" sz="1100" dirty="0">
+                <a:solidFill>
+                  <a:srgbClr val="8A8984"/>
+                </a:solidFill>
+                <a:latin typeface="Calibri" pitchFamily="34" charset="0"/>
+                <a:ea typeface="Calibri" pitchFamily="34" charset="-122"/>
+                <a:cs typeface="Calibri" pitchFamily="34" charset="-120"/>
+              </a:rPr>
+              <a:t>3 pts</a:t>
+            </a:r>
+            <a:endParaRPr lang="en-US" sz="1100" dirty="0"/>
+          </a:p>
+        </p:txBody>
+      </p:sp>
+      <p:sp>
+        <p:nvSpPr>
+          <p:cNvPr id="27" name="Shape 24"/>
+          <p:cNvSpPr/>
+          <p:nvPr/>
+        </p:nvSpPr>
+        <p:spPr>
+          <a:xfrm>
+            <a:off x="3200400" y="2148840"/>
+            <a:ext cx="2331720" cy="475488"/>
+          </a:xfrm>
+          <a:prstGeom prst="roundRect">
+            <a:avLst>
+              <a:gd name="adj" fmla="val 15385"/>
+            </a:avLst>
+          </a:prstGeom>
+          <a:solidFill>
+            <a:srgbClr val="FFF4ED"/>
+          </a:solidFill>
+          <a:ln w="9525">
+            <a:solidFill>
+              <a:srgbClr val="F5D0BD"/>
+            </a:solidFill>
+            <a:prstDash val="solid"/>
+          </a:ln>
+        </p:spPr>
+      </p:sp>
+      <p:sp>
+        <p:nvSpPr>
+          <p:cNvPr id="28" name="Text 25"/>
+          <p:cNvSpPr/>
+          <p:nvPr/>
+        </p:nvSpPr>
+        <p:spPr>
+          <a:xfrm>
+            <a:off x="3337560" y="2276856"/>
+            <a:ext cx="1920240" cy="274320"/>
+          </a:xfrm>
+          <a:prstGeom prst="rect">
+            <a:avLst/>
+          </a:prstGeom>
+          <a:noFill/>
+          <a:ln/>
+        </p:spPr>
+        <p:txBody>
+          <a:bodyPr wrap="square" lIns="0" tIns="0" rIns="0" bIns="0" rtlCol="0" anchor="t"/>
+          <a:lstStyle/>
+          <a:p>
+            <a:pPr indent="0" marL="0">
+              <a:buNone/>
+            </a:pPr>
+            <a:r>
+              <a:rPr lang="en-US" sz="1200" b="1" dirty="0">
+                <a:solidFill>
+                  <a:srgbClr val="1A1A1A"/>
+                </a:solidFill>
+                <a:latin typeface="Calibri" pitchFamily="34" charset="0"/>
+                <a:ea typeface="Calibri" pitchFamily="34" charset="-122"/>
+                <a:cs typeface="Calibri" pitchFamily="34" charset="-120"/>
+              </a:rPr>
+              <a:t>HU05  </a:t>
+            </a:r>
+            <a:pPr indent="0" marL="0">
+              <a:buNone/>
+            </a:pPr>
+            <a:r>
+              <a:rPr lang="en-US" sz="1200" dirty="0">
+                <a:solidFill>
+                  <a:srgbClr val="1A1A1A"/>
+                </a:solidFill>
+                <a:latin typeface="Calibri" pitchFamily="34" charset="0"/>
+                <a:ea typeface="Calibri" pitchFamily="34" charset="-122"/>
+                <a:cs typeface="Calibri" pitchFamily="34" charset="-120"/>
+              </a:rPr>
+              <a:t>Agrupar en clips</a:t>
+            </a:r>
+            <a:endParaRPr lang="en-US" sz="1200" dirty="0"/>
+          </a:p>
+        </p:txBody>
+      </p:sp>
+      <p:sp>
+        <p:nvSpPr>
+          <p:cNvPr id="29" name="Text 26"/>
+          <p:cNvSpPr/>
+          <p:nvPr/>
+        </p:nvSpPr>
+        <p:spPr>
+          <a:xfrm>
+            <a:off x="5166360" y="2276856"/>
+            <a:ext cx="256032" cy="274320"/>
+          </a:xfrm>
+          <a:prstGeom prst="rect">
+            <a:avLst/>
+          </a:prstGeom>
+          <a:noFill/>
+          <a:ln/>
+        </p:spPr>
+        <p:txBody>
+          <a:bodyPr wrap="square" lIns="0" tIns="0" rIns="0" bIns="0" rtlCol="0" anchor="t"/>
+          <a:lstStyle/>
+          <a:p>
+            <a:pPr algn="r" indent="0" marL="0">
+              <a:buNone/>
+            </a:pPr>
+            <a:r>
+              <a:rPr lang="en-US" sz="1200" dirty="0">
+                <a:solidFill>
+                  <a:srgbClr val="8A8984"/>
+                </a:solidFill>
+                <a:latin typeface="Calibri" pitchFamily="34" charset="0"/>
+                <a:ea typeface="Calibri" pitchFamily="34" charset="-122"/>
+                <a:cs typeface="Calibri" pitchFamily="34" charset="-120"/>
+              </a:rPr>
+              <a:t>3</a:t>
+            </a:r>
+            <a:endParaRPr lang="en-US" sz="1200" dirty="0"/>
+          </a:p>
+        </p:txBody>
+      </p:sp>
+      <p:sp>
+        <p:nvSpPr>
+          <p:cNvPr id="30" name="Text 27"/>
+          <p:cNvSpPr/>
+          <p:nvPr/>
+        </p:nvSpPr>
+        <p:spPr>
+          <a:xfrm>
+            <a:off x="3200400" y="2743200"/>
+            <a:ext cx="2331720" cy="1097280"/>
+          </a:xfrm>
+          <a:prstGeom prst="rect">
+            <a:avLst/>
+          </a:prstGeom>
+          <a:noFill/>
+          <a:ln/>
+        </p:spPr>
+        <p:txBody>
+          <a:bodyPr wrap="square" lIns="0" tIns="0" rIns="0" bIns="0" rtlCol="0" anchor="t"/>
+          <a:lstStyle/>
+          <a:p>
+            <a:pPr indent="0" marL="0">
+              <a:buNone/>
+            </a:pPr>
+            <a:r>
+              <a:rPr lang="en-US" sz="1200" dirty="0">
+                <a:solidFill>
+                  <a:srgbClr val="57534E"/>
+                </a:solidFill>
+                <a:latin typeface="Calibri" pitchFamily="34" charset="0"/>
+                <a:ea typeface="Calibri" pitchFamily="34" charset="-122"/>
+                <a:cs typeface="Calibri" pitchFamily="34" charset="-120"/>
+              </a:rPr>
+              <a:t>Agrupa los clips; falta darles el formato de entrada del modelo temporal. Se cierra con HU07.</a:t>
+            </a:r>
+            <a:endParaRPr lang="en-US" sz="1200" dirty="0"/>
+          </a:p>
+        </p:txBody>
+      </p:sp>
+      <p:sp>
+        <p:nvSpPr>
+          <p:cNvPr id="31" name="Text 28"/>
+          <p:cNvSpPr/>
+          <p:nvPr/>
+        </p:nvSpPr>
+        <p:spPr>
+          <a:xfrm>
+            <a:off x="5669280" y="1783080"/>
+            <a:ext cx="2011680" cy="274320"/>
+          </a:xfrm>
+          <a:prstGeom prst="rect">
+            <a:avLst/>
+          </a:prstGeom>
+          <a:noFill/>
+          <a:ln/>
+        </p:spPr>
+        <p:txBody>
+          <a:bodyPr wrap="square" lIns="0" tIns="0" rIns="0" bIns="0" rtlCol="0" anchor="t"/>
+          <a:lstStyle/>
+          <a:p>
+            <a:pPr indent="0" marL="0">
+              <a:buNone/>
+            </a:pPr>
+            <a:r>
+              <a:rPr lang="en-US" sz="1100" b="1" spc="100" kern="0" dirty="0">
+                <a:solidFill>
                   <a:srgbClr val="2F855A"/>
                 </a:solidFill>
                 <a:latin typeface="Calibri" pitchFamily="34" charset="0"/>
                 <a:ea typeface="Calibri" pitchFamily="34" charset="-122"/>
                 <a:cs typeface="Calibri" pitchFamily="34" charset="-120"/>
               </a:rPr>
-              <a:t>HECHO · POR ACEPTAR</a:t>
+              <a:t>TERMINADA · POR ACEPTAR</a:t>
             </a:r>
             <a:endParaRPr lang="en-US" sz="1100" dirty="0"/>
           </a:p>
@@ -21411,14 +22452,14 @@
       </p:sp>
       <p:sp>
         <p:nvSpPr>
-          <p:cNvPr id="9" name="Text 6"/>
-          <p:cNvSpPr/>
-          <p:nvPr/>
-        </p:nvSpPr>
-        <p:spPr>
-          <a:xfrm>
-            <a:off x="2331720" y="1783080"/>
-            <a:ext cx="731520" cy="274320"/>
+          <p:cNvPr id="32" name="Text 29"/>
+          <p:cNvSpPr/>
+          <p:nvPr/>
+        </p:nvSpPr>
+        <p:spPr>
+          <a:xfrm>
+            <a:off x="7498080" y="1783080"/>
+            <a:ext cx="502920" cy="274320"/>
           </a:xfrm>
           <a:prstGeom prst="rect">
             <a:avLst/>
@@ -21450,13 +22491,13 @@
       </p:sp>
       <p:sp>
         <p:nvSpPr>
-          <p:cNvPr id="10" name="Shape 7"/>
-          <p:cNvSpPr/>
-          <p:nvPr/>
-        </p:nvSpPr>
-        <p:spPr>
-          <a:xfrm>
-            <a:off x="731520" y="2148840"/>
+          <p:cNvPr id="33" name="Shape 30"/>
+          <p:cNvSpPr/>
+          <p:nvPr/>
+        </p:nvSpPr>
+        <p:spPr>
+          <a:xfrm>
+            <a:off x="5669280" y="2148840"/>
             <a:ext cx="2331720" cy="475488"/>
           </a:xfrm>
           <a:prstGeom prst="roundRect">
@@ -21477,13 +22518,13 @@
       </p:sp>
       <p:sp>
         <p:nvSpPr>
-          <p:cNvPr id="11" name="Text 8"/>
-          <p:cNvSpPr/>
-          <p:nvPr/>
-        </p:nvSpPr>
-        <p:spPr>
-          <a:xfrm>
-            <a:off x="868680" y="2276856"/>
+          <p:cNvPr id="34" name="Text 31"/>
+          <p:cNvSpPr/>
+          <p:nvPr/>
+        </p:nvSpPr>
+        <p:spPr>
+          <a:xfrm>
+            <a:off x="5806440" y="2276856"/>
             <a:ext cx="1920240" cy="274320"/>
           </a:xfrm>
           <a:prstGeom prst="rect">
@@ -21530,13 +22571,13 @@
       </p:sp>
       <p:sp>
         <p:nvSpPr>
-          <p:cNvPr id="12" name="Text 9"/>
-          <p:cNvSpPr/>
-          <p:nvPr/>
-        </p:nvSpPr>
-        <p:spPr>
-          <a:xfrm>
-            <a:off x="2697480" y="2276856"/>
+          <p:cNvPr id="35" name="Text 32"/>
+          <p:cNvSpPr/>
+          <p:nvPr/>
+        </p:nvSpPr>
+        <p:spPr>
+          <a:xfrm>
+            <a:off x="7635240" y="2276856"/>
             <a:ext cx="256032" cy="274320"/>
           </a:xfrm>
           <a:prstGeom prst="rect">
@@ -21569,13 +22610,13 @@
       </p:sp>
       <p:sp>
         <p:nvSpPr>
-          <p:cNvPr id="13" name="Shape 10"/>
-          <p:cNvSpPr/>
-          <p:nvPr/>
-        </p:nvSpPr>
-        <p:spPr>
-          <a:xfrm>
-            <a:off x="731520" y="2715768"/>
+          <p:cNvPr id="36" name="Shape 33"/>
+          <p:cNvSpPr/>
+          <p:nvPr/>
+        </p:nvSpPr>
+        <p:spPr>
+          <a:xfrm>
+            <a:off x="5669280" y="2715768"/>
             <a:ext cx="2331720" cy="475488"/>
           </a:xfrm>
           <a:prstGeom prst="roundRect">
@@ -21596,13 +22637,13 @@
       </p:sp>
       <p:sp>
         <p:nvSpPr>
-          <p:cNvPr id="14" name="Text 11"/>
-          <p:cNvSpPr/>
-          <p:nvPr/>
-        </p:nvSpPr>
-        <p:spPr>
-          <a:xfrm>
-            <a:off x="868680" y="2843784"/>
+          <p:cNvPr id="37" name="Text 34"/>
+          <p:cNvSpPr/>
+          <p:nvPr/>
+        </p:nvSpPr>
+        <p:spPr>
+          <a:xfrm>
+            <a:off x="5806440" y="2843784"/>
             <a:ext cx="1920240" cy="274320"/>
           </a:xfrm>
           <a:prstGeom prst="rect">
@@ -21649,13 +22690,13 @@
       </p:sp>
       <p:sp>
         <p:nvSpPr>
-          <p:cNvPr id="15" name="Text 12"/>
-          <p:cNvSpPr/>
-          <p:nvPr/>
-        </p:nvSpPr>
-        <p:spPr>
-          <a:xfrm>
-            <a:off x="2697480" y="2843784"/>
+          <p:cNvPr id="38" name="Text 35"/>
+          <p:cNvSpPr/>
+          <p:nvPr/>
+        </p:nvSpPr>
+        <p:spPr>
+          <a:xfrm>
+            <a:off x="7635240" y="2843784"/>
             <a:ext cx="256032" cy="274320"/>
           </a:xfrm>
           <a:prstGeom prst="rect">
@@ -21688,13 +22729,13 @@
       </p:sp>
       <p:sp>
         <p:nvSpPr>
-          <p:cNvPr id="16" name="Shape 13"/>
-          <p:cNvSpPr/>
-          <p:nvPr/>
-        </p:nvSpPr>
-        <p:spPr>
-          <a:xfrm>
-            <a:off x="731520" y="3282696"/>
+          <p:cNvPr id="39" name="Shape 36"/>
+          <p:cNvSpPr/>
+          <p:nvPr/>
+        </p:nvSpPr>
+        <p:spPr>
+          <a:xfrm>
+            <a:off x="5669280" y="3282696"/>
             <a:ext cx="2331720" cy="475488"/>
           </a:xfrm>
           <a:prstGeom prst="roundRect">
@@ -21715,13 +22756,13 @@
       </p:sp>
       <p:sp>
         <p:nvSpPr>
-          <p:cNvPr id="17" name="Text 14"/>
-          <p:cNvSpPr/>
-          <p:nvPr/>
-        </p:nvSpPr>
-        <p:spPr>
-          <a:xfrm>
-            <a:off x="868680" y="3410712"/>
+          <p:cNvPr id="40" name="Text 37"/>
+          <p:cNvSpPr/>
+          <p:nvPr/>
+        </p:nvSpPr>
+        <p:spPr>
+          <a:xfrm>
+            <a:off x="5806440" y="3410712"/>
             <a:ext cx="1920240" cy="274320"/>
           </a:xfrm>
           <a:prstGeom prst="rect">
@@ -21768,13 +22809,13 @@
       </p:sp>
       <p:sp>
         <p:nvSpPr>
-          <p:cNvPr id="18" name="Text 15"/>
-          <p:cNvSpPr/>
-          <p:nvPr/>
-        </p:nvSpPr>
-        <p:spPr>
-          <a:xfrm>
-            <a:off x="2697480" y="3410712"/>
+          <p:cNvPr id="41" name="Text 38"/>
+          <p:cNvSpPr/>
+          <p:nvPr/>
+        </p:nvSpPr>
+        <p:spPr>
+          <a:xfrm>
+            <a:off x="7635240" y="3410712"/>
             <a:ext cx="256032" cy="274320"/>
           </a:xfrm>
           <a:prstGeom prst="rect">
@@ -21807,13 +22848,13 @@
       </p:sp>
       <p:sp>
         <p:nvSpPr>
-          <p:cNvPr id="19" name="Shape 16"/>
-          <p:cNvSpPr/>
-          <p:nvPr/>
-        </p:nvSpPr>
-        <p:spPr>
-          <a:xfrm>
-            <a:off x="731520" y="3849624"/>
+          <p:cNvPr id="42" name="Shape 39"/>
+          <p:cNvSpPr/>
+          <p:nvPr/>
+        </p:nvSpPr>
+        <p:spPr>
+          <a:xfrm>
+            <a:off x="5669280" y="3849624"/>
             <a:ext cx="2331720" cy="475488"/>
           </a:xfrm>
           <a:prstGeom prst="roundRect">
@@ -21834,13 +22875,13 @@
       </p:sp>
       <p:sp>
         <p:nvSpPr>
-          <p:cNvPr id="20" name="Text 17"/>
-          <p:cNvSpPr/>
-          <p:nvPr/>
-        </p:nvSpPr>
-        <p:spPr>
-          <a:xfrm>
-            <a:off x="868680" y="3977640"/>
+          <p:cNvPr id="43" name="Text 40"/>
+          <p:cNvSpPr/>
+          <p:nvPr/>
+        </p:nvSpPr>
+        <p:spPr>
+          <a:xfrm>
+            <a:off x="5806440" y="3977640"/>
             <a:ext cx="1920240" cy="274320"/>
           </a:xfrm>
           <a:prstGeom prst="rect">
@@ -21887,13 +22928,13 @@
       </p:sp>
       <p:sp>
         <p:nvSpPr>
-          <p:cNvPr id="21" name="Text 18"/>
-          <p:cNvSpPr/>
-          <p:nvPr/>
-        </p:nvSpPr>
-        <p:spPr>
-          <a:xfrm>
-            <a:off x="2697480" y="3977640"/>
+          <p:cNvPr id="44" name="Text 41"/>
+          <p:cNvSpPr/>
+          <p:nvPr/>
+        </p:nvSpPr>
+        <p:spPr>
+          <a:xfrm>
+            <a:off x="7635240" y="3977640"/>
             <a:ext cx="256032" cy="274320"/>
           </a:xfrm>
           <a:prstGeom prst="rect">
@@ -21926,13 +22967,13 @@
       </p:sp>
       <p:sp>
         <p:nvSpPr>
-          <p:cNvPr id="22" name="Shape 19"/>
-          <p:cNvSpPr/>
-          <p:nvPr/>
-        </p:nvSpPr>
-        <p:spPr>
-          <a:xfrm>
-            <a:off x="731520" y="4416552"/>
+          <p:cNvPr id="45" name="Shape 42"/>
+          <p:cNvSpPr/>
+          <p:nvPr/>
+        </p:nvSpPr>
+        <p:spPr>
+          <a:xfrm>
+            <a:off x="5669280" y="4416552"/>
             <a:ext cx="2331720" cy="475488"/>
           </a:xfrm>
           <a:prstGeom prst="roundRect">
@@ -21953,13 +22994,13 @@
       </p:sp>
       <p:sp>
         <p:nvSpPr>
-          <p:cNvPr id="23" name="Text 20"/>
-          <p:cNvSpPr/>
-          <p:nvPr/>
-        </p:nvSpPr>
-        <p:spPr>
-          <a:xfrm>
-            <a:off x="868680" y="4544568"/>
+          <p:cNvPr id="46" name="Text 43"/>
+          <p:cNvSpPr/>
+          <p:nvPr/>
+        </p:nvSpPr>
+        <p:spPr>
+          <a:xfrm>
+            <a:off x="5806440" y="4544568"/>
             <a:ext cx="1920240" cy="274320"/>
           </a:xfrm>
           <a:prstGeom prst="rect">
@@ -22006,13 +23047,13 @@
       </p:sp>
       <p:sp>
         <p:nvSpPr>
-          <p:cNvPr id="24" name="Text 21"/>
-          <p:cNvSpPr/>
-          <p:nvPr/>
-        </p:nvSpPr>
-        <p:spPr>
-          <a:xfrm>
-            <a:off x="2697480" y="4544568"/>
+          <p:cNvPr id="47" name="Text 44"/>
+          <p:cNvSpPr/>
+          <p:nvPr/>
+        </p:nvSpPr>
+        <p:spPr>
+          <a:xfrm>
+            <a:off x="7635240" y="4544568"/>
             <a:ext cx="256032" cy="274320"/>
           </a:xfrm>
           <a:prstGeom prst="rect">
@@ -22045,13 +23086,13 @@
       </p:sp>
       <p:sp>
         <p:nvSpPr>
-          <p:cNvPr id="25" name="Shape 22"/>
-          <p:cNvSpPr/>
-          <p:nvPr/>
-        </p:nvSpPr>
-        <p:spPr>
-          <a:xfrm>
-            <a:off x="731520" y="4983480"/>
+          <p:cNvPr id="48" name="Shape 45"/>
+          <p:cNvSpPr/>
+          <p:nvPr/>
+        </p:nvSpPr>
+        <p:spPr>
+          <a:xfrm>
+            <a:off x="5669280" y="4983480"/>
             <a:ext cx="2331720" cy="475488"/>
           </a:xfrm>
           <a:prstGeom prst="roundRect">
@@ -22072,13 +23113,13 @@
       </p:sp>
       <p:sp>
         <p:nvSpPr>
-          <p:cNvPr id="26" name="Text 23"/>
-          <p:cNvSpPr/>
-          <p:nvPr/>
-        </p:nvSpPr>
-        <p:spPr>
-          <a:xfrm>
-            <a:off x="868680" y="5111496"/>
+          <p:cNvPr id="49" name="Text 46"/>
+          <p:cNvSpPr/>
+          <p:nvPr/>
+        </p:nvSpPr>
+        <p:spPr>
+          <a:xfrm>
+            <a:off x="5806440" y="5111496"/>
             <a:ext cx="1920240" cy="274320"/>
           </a:xfrm>
           <a:prstGeom prst="rect">
@@ -22125,13 +23166,13 @@
       </p:sp>
       <p:sp>
         <p:nvSpPr>
-          <p:cNvPr id="27" name="Text 24"/>
-          <p:cNvSpPr/>
-          <p:nvPr/>
-        </p:nvSpPr>
-        <p:spPr>
-          <a:xfrm>
-            <a:off x="2697480" y="5111496"/>
+          <p:cNvPr id="50" name="Text 47"/>
+          <p:cNvSpPr/>
+          <p:nvPr/>
+        </p:nvSpPr>
+        <p:spPr>
+          <a:xfrm>
+            <a:off x="7635240" y="5111496"/>
             <a:ext cx="256032" cy="274320"/>
           </a:xfrm>
           <a:prstGeom prst="rect">
@@ -22157,915 +23198,6 @@
                 <a:cs typeface="Calibri" pitchFamily="34" charset="-120"/>
               </a:rPr>
               <a:t>1</a:t>
-            </a:r>
-            <a:endParaRPr lang="en-US" sz="1200" dirty="0"/>
-          </a:p>
-        </p:txBody>
-      </p:sp>
-      <p:sp>
-        <p:nvSpPr>
-          <p:cNvPr id="28" name="Text 25"/>
-          <p:cNvSpPr/>
-          <p:nvPr/>
-        </p:nvSpPr>
-        <p:spPr>
-          <a:xfrm>
-            <a:off x="3200400" y="1783080"/>
-            <a:ext cx="1828800" cy="274320"/>
-          </a:xfrm>
-          <a:prstGeom prst="rect">
-            <a:avLst/>
-          </a:prstGeom>
-          <a:noFill/>
-          <a:ln/>
-        </p:spPr>
-        <p:txBody>
-          <a:bodyPr wrap="square" lIns="0" tIns="0" rIns="0" bIns="0" rtlCol="0" anchor="t"/>
-          <a:lstStyle/>
-          <a:p>
-            <a:pPr indent="0" marL="0">
-              <a:buNone/>
-            </a:pPr>
-            <a:r>
-              <a:rPr lang="en-US" sz="1100" b="1" spc="100" kern="0" dirty="0">
-                <a:solidFill>
-                  <a:srgbClr val="C2410C"/>
-                </a:solidFill>
-                <a:latin typeface="Calibri" pitchFamily="34" charset="0"/>
-                <a:ea typeface="Calibri" pitchFamily="34" charset="-122"/>
-                <a:cs typeface="Calibri" pitchFamily="34" charset="-120"/>
-              </a:rPr>
-              <a:t>EN CIERRE</a:t>
-            </a:r>
-            <a:endParaRPr lang="en-US" sz="1100" dirty="0"/>
-          </a:p>
-        </p:txBody>
-      </p:sp>
-      <p:sp>
-        <p:nvSpPr>
-          <p:cNvPr id="29" name="Text 26"/>
-          <p:cNvSpPr/>
-          <p:nvPr/>
-        </p:nvSpPr>
-        <p:spPr>
-          <a:xfrm>
-            <a:off x="4800600" y="1783080"/>
-            <a:ext cx="731520" cy="274320"/>
-          </a:xfrm>
-          <a:prstGeom prst="rect">
-            <a:avLst/>
-          </a:prstGeom>
-          <a:noFill/>
-          <a:ln/>
-        </p:spPr>
-        <p:txBody>
-          <a:bodyPr wrap="square" lIns="0" tIns="0" rIns="0" bIns="0" rtlCol="0" anchor="t"/>
-          <a:lstStyle/>
-          <a:p>
-            <a:pPr algn="r" indent="0" marL="0">
-              <a:buNone/>
-            </a:pPr>
-            <a:r>
-              <a:rPr lang="en-US" sz="1100" dirty="0">
-                <a:solidFill>
-                  <a:srgbClr val="8A8984"/>
-                </a:solidFill>
-                <a:latin typeface="Calibri" pitchFamily="34" charset="0"/>
-                <a:ea typeface="Calibri" pitchFamily="34" charset="-122"/>
-                <a:cs typeface="Calibri" pitchFamily="34" charset="-120"/>
-              </a:rPr>
-              <a:t>3 pts</a:t>
-            </a:r>
-            <a:endParaRPr lang="en-US" sz="1100" dirty="0"/>
-          </a:p>
-        </p:txBody>
-      </p:sp>
-      <p:sp>
-        <p:nvSpPr>
-          <p:cNvPr id="30" name="Shape 27"/>
-          <p:cNvSpPr/>
-          <p:nvPr/>
-        </p:nvSpPr>
-        <p:spPr>
-          <a:xfrm>
-            <a:off x="3200400" y="2148840"/>
-            <a:ext cx="2331720" cy="475488"/>
-          </a:xfrm>
-          <a:prstGeom prst="roundRect">
-            <a:avLst>
-              <a:gd name="adj" fmla="val 15385"/>
-            </a:avLst>
-          </a:prstGeom>
-          <a:solidFill>
-            <a:srgbClr val="FFF4ED"/>
-          </a:solidFill>
-          <a:ln w="9525">
-            <a:solidFill>
-              <a:srgbClr val="F5D0BD"/>
-            </a:solidFill>
-            <a:prstDash val="solid"/>
-          </a:ln>
-        </p:spPr>
-      </p:sp>
-      <p:sp>
-        <p:nvSpPr>
-          <p:cNvPr id="31" name="Text 28"/>
-          <p:cNvSpPr/>
-          <p:nvPr/>
-        </p:nvSpPr>
-        <p:spPr>
-          <a:xfrm>
-            <a:off x="3337560" y="2276856"/>
-            <a:ext cx="1920240" cy="274320"/>
-          </a:xfrm>
-          <a:prstGeom prst="rect">
-            <a:avLst/>
-          </a:prstGeom>
-          <a:noFill/>
-          <a:ln/>
-        </p:spPr>
-        <p:txBody>
-          <a:bodyPr wrap="square" lIns="0" tIns="0" rIns="0" bIns="0" rtlCol="0" anchor="t"/>
-          <a:lstStyle/>
-          <a:p>
-            <a:pPr indent="0" marL="0">
-              <a:buNone/>
-            </a:pPr>
-            <a:r>
-              <a:rPr lang="en-US" sz="1200" b="1" dirty="0">
-                <a:solidFill>
-                  <a:srgbClr val="1A1A1A"/>
-                </a:solidFill>
-                <a:latin typeface="Calibri" pitchFamily="34" charset="0"/>
-                <a:ea typeface="Calibri" pitchFamily="34" charset="-122"/>
-                <a:cs typeface="Calibri" pitchFamily="34" charset="-120"/>
-              </a:rPr>
-              <a:t>HU05  </a:t>
-            </a:r>
-            <a:pPr indent="0" marL="0">
-              <a:buNone/>
-            </a:pPr>
-            <a:r>
-              <a:rPr lang="en-US" sz="1200" dirty="0">
-                <a:solidFill>
-                  <a:srgbClr val="1A1A1A"/>
-                </a:solidFill>
-                <a:latin typeface="Calibri" pitchFamily="34" charset="0"/>
-                <a:ea typeface="Calibri" pitchFamily="34" charset="-122"/>
-                <a:cs typeface="Calibri" pitchFamily="34" charset="-120"/>
-              </a:rPr>
-              <a:t>Agrupar en clips</a:t>
-            </a:r>
-            <a:endParaRPr lang="en-US" sz="1200" dirty="0"/>
-          </a:p>
-        </p:txBody>
-      </p:sp>
-      <p:sp>
-        <p:nvSpPr>
-          <p:cNvPr id="32" name="Text 29"/>
-          <p:cNvSpPr/>
-          <p:nvPr/>
-        </p:nvSpPr>
-        <p:spPr>
-          <a:xfrm>
-            <a:off x="5166360" y="2276856"/>
-            <a:ext cx="256032" cy="274320"/>
-          </a:xfrm>
-          <a:prstGeom prst="rect">
-            <a:avLst/>
-          </a:prstGeom>
-          <a:noFill/>
-          <a:ln/>
-        </p:spPr>
-        <p:txBody>
-          <a:bodyPr wrap="square" lIns="0" tIns="0" rIns="0" bIns="0" rtlCol="0" anchor="t"/>
-          <a:lstStyle/>
-          <a:p>
-            <a:pPr algn="r" indent="0" marL="0">
-              <a:buNone/>
-            </a:pPr>
-            <a:r>
-              <a:rPr lang="en-US" sz="1200" dirty="0">
-                <a:solidFill>
-                  <a:srgbClr val="8A8984"/>
-                </a:solidFill>
-                <a:latin typeface="Calibri" pitchFamily="34" charset="0"/>
-                <a:ea typeface="Calibri" pitchFamily="34" charset="-122"/>
-                <a:cs typeface="Calibri" pitchFamily="34" charset="-120"/>
-              </a:rPr>
-              <a:t>3</a:t>
-            </a:r>
-            <a:endParaRPr lang="en-US" sz="1200" dirty="0"/>
-          </a:p>
-        </p:txBody>
-      </p:sp>
-      <p:sp>
-        <p:nvSpPr>
-          <p:cNvPr id="33" name="Text 30"/>
-          <p:cNvSpPr/>
-          <p:nvPr/>
-        </p:nvSpPr>
-        <p:spPr>
-          <a:xfrm>
-            <a:off x="3200400" y="2743200"/>
-            <a:ext cx="2331720" cy="1097280"/>
-          </a:xfrm>
-          <a:prstGeom prst="rect">
-            <a:avLst/>
-          </a:prstGeom>
-          <a:noFill/>
-          <a:ln/>
-        </p:spPr>
-        <p:txBody>
-          <a:bodyPr wrap="square" lIns="0" tIns="0" rIns="0" bIns="0" rtlCol="0" anchor="t"/>
-          <a:lstStyle/>
-          <a:p>
-            <a:pPr indent="0" marL="0">
-              <a:buNone/>
-            </a:pPr>
-            <a:r>
-              <a:rPr lang="en-US" sz="1200" dirty="0">
-                <a:solidFill>
-                  <a:srgbClr val="57534E"/>
-                </a:solidFill>
-                <a:latin typeface="Calibri" pitchFamily="34" charset="0"/>
-                <a:ea typeface="Calibri" pitchFamily="34" charset="-122"/>
-                <a:cs typeface="Calibri" pitchFamily="34" charset="-120"/>
-              </a:rPr>
-              <a:t>Agrupa los clips; falta darles el formato de entrada del modelo temporal. Se cierra con HU07.</a:t>
-            </a:r>
-            <a:endParaRPr lang="en-US" sz="1200" dirty="0"/>
-          </a:p>
-        </p:txBody>
-      </p:sp>
-      <p:sp>
-        <p:nvSpPr>
-          <p:cNvPr id="34" name="Text 31"/>
-          <p:cNvSpPr/>
-          <p:nvPr/>
-        </p:nvSpPr>
-        <p:spPr>
-          <a:xfrm>
-            <a:off x="5669280" y="1783080"/>
-            <a:ext cx="1828800" cy="274320"/>
-          </a:xfrm>
-          <a:prstGeom prst="rect">
-            <a:avLst/>
-          </a:prstGeom>
-          <a:noFill/>
-          <a:ln/>
-        </p:spPr>
-        <p:txBody>
-          <a:bodyPr wrap="square" lIns="0" tIns="0" rIns="0" bIns="0" rtlCol="0" anchor="t"/>
-          <a:lstStyle/>
-          <a:p>
-            <a:pPr indent="0" marL="0">
-              <a:buNone/>
-            </a:pPr>
-            <a:r>
-              <a:rPr lang="en-US" sz="1100" b="1" spc="100" kern="0" dirty="0">
-                <a:solidFill>
-                  <a:srgbClr val="8A8984"/>
-                </a:solidFill>
-                <a:latin typeface="Calibri" pitchFamily="34" charset="0"/>
-                <a:ea typeface="Calibri" pitchFamily="34" charset="-122"/>
-                <a:cs typeface="Calibri" pitchFamily="34" charset="-120"/>
-              </a:rPr>
-              <a:t>POR HACER</a:t>
-            </a:r>
-            <a:endParaRPr lang="en-US" sz="1100" dirty="0"/>
-          </a:p>
-        </p:txBody>
-      </p:sp>
-      <p:sp>
-        <p:nvSpPr>
-          <p:cNvPr id="35" name="Text 32"/>
-          <p:cNvSpPr/>
-          <p:nvPr/>
-        </p:nvSpPr>
-        <p:spPr>
-          <a:xfrm>
-            <a:off x="7269480" y="1783080"/>
-            <a:ext cx="731520" cy="274320"/>
-          </a:xfrm>
-          <a:prstGeom prst="rect">
-            <a:avLst/>
-          </a:prstGeom>
-          <a:noFill/>
-          <a:ln/>
-        </p:spPr>
-        <p:txBody>
-          <a:bodyPr wrap="square" lIns="0" tIns="0" rIns="0" bIns="0" rtlCol="0" anchor="t"/>
-          <a:lstStyle/>
-          <a:p>
-            <a:pPr algn="r" indent="0" marL="0">
-              <a:buNone/>
-            </a:pPr>
-            <a:r>
-              <a:rPr lang="en-US" sz="1100" dirty="0">
-                <a:solidFill>
-                  <a:srgbClr val="8A8984"/>
-                </a:solidFill>
-                <a:latin typeface="Calibri" pitchFamily="34" charset="0"/>
-                <a:ea typeface="Calibri" pitchFamily="34" charset="-122"/>
-                <a:cs typeface="Calibri" pitchFamily="34" charset="-120"/>
-              </a:rPr>
-              <a:t>16 pts</a:t>
-            </a:r>
-            <a:endParaRPr lang="en-US" sz="1100" dirty="0"/>
-          </a:p>
-        </p:txBody>
-      </p:sp>
-      <p:sp>
-        <p:nvSpPr>
-          <p:cNvPr id="36" name="Shape 33"/>
-          <p:cNvSpPr/>
-          <p:nvPr/>
-        </p:nvSpPr>
-        <p:spPr>
-          <a:xfrm>
-            <a:off x="5669280" y="2148840"/>
-            <a:ext cx="2331720" cy="475488"/>
-          </a:xfrm>
-          <a:prstGeom prst="roundRect">
-            <a:avLst>
-              <a:gd name="adj" fmla="val 15385"/>
-            </a:avLst>
-          </a:prstGeom>
-          <a:solidFill>
-            <a:srgbClr val="FFFFFF"/>
-          </a:solidFill>
-          <a:ln w="9525">
-            <a:solidFill>
-              <a:srgbClr val="E7E5E4"/>
-            </a:solidFill>
-            <a:prstDash val="solid"/>
-          </a:ln>
-        </p:spPr>
-      </p:sp>
-      <p:sp>
-        <p:nvSpPr>
-          <p:cNvPr id="37" name="Text 34"/>
-          <p:cNvSpPr/>
-          <p:nvPr/>
-        </p:nvSpPr>
-        <p:spPr>
-          <a:xfrm>
-            <a:off x="5806440" y="2276856"/>
-            <a:ext cx="1920240" cy="274320"/>
-          </a:xfrm>
-          <a:prstGeom prst="rect">
-            <a:avLst/>
-          </a:prstGeom>
-          <a:noFill/>
-          <a:ln/>
-        </p:spPr>
-        <p:txBody>
-          <a:bodyPr wrap="square" lIns="0" tIns="0" rIns="0" bIns="0" rtlCol="0" anchor="t"/>
-          <a:lstStyle/>
-          <a:p>
-            <a:pPr indent="0" marL="0">
-              <a:buNone/>
-            </a:pPr>
-            <a:r>
-              <a:rPr lang="en-US" sz="1200" b="1" dirty="0">
-                <a:solidFill>
-                  <a:srgbClr val="1A1A1A"/>
-                </a:solidFill>
-                <a:latin typeface="Calibri" pitchFamily="34" charset="0"/>
-                <a:ea typeface="Calibri" pitchFamily="34" charset="-122"/>
-                <a:cs typeface="Calibri" pitchFamily="34" charset="-120"/>
-              </a:rPr>
-              <a:t>HU07  </a:t>
-            </a:r>
-            <a:pPr indent="0" marL="0">
-              <a:buNone/>
-            </a:pPr>
-            <a:r>
-              <a:rPr lang="en-US" sz="1200" dirty="0">
-                <a:solidFill>
-                  <a:srgbClr val="1A1A1A"/>
-                </a:solidFill>
-                <a:latin typeface="Calibri" pitchFamily="34" charset="0"/>
-                <a:ea typeface="Calibri" pitchFamily="34" charset="-122"/>
-                <a:cs typeface="Calibri" pitchFamily="34" charset="-120"/>
-              </a:rPr>
-              <a:t>Procesar con ConvLSTM</a:t>
-            </a:r>
-            <a:endParaRPr lang="en-US" sz="1200" dirty="0"/>
-          </a:p>
-        </p:txBody>
-      </p:sp>
-      <p:sp>
-        <p:nvSpPr>
-          <p:cNvPr id="38" name="Text 35"/>
-          <p:cNvSpPr/>
-          <p:nvPr/>
-        </p:nvSpPr>
-        <p:spPr>
-          <a:xfrm>
-            <a:off x="7635240" y="2276856"/>
-            <a:ext cx="256032" cy="274320"/>
-          </a:xfrm>
-          <a:prstGeom prst="rect">
-            <a:avLst/>
-          </a:prstGeom>
-          <a:noFill/>
-          <a:ln/>
-        </p:spPr>
-        <p:txBody>
-          <a:bodyPr wrap="square" lIns="0" tIns="0" rIns="0" bIns="0" rtlCol="0" anchor="t"/>
-          <a:lstStyle/>
-          <a:p>
-            <a:pPr algn="r" indent="0" marL="0">
-              <a:buNone/>
-            </a:pPr>
-            <a:r>
-              <a:rPr lang="en-US" sz="1200" dirty="0">
-                <a:solidFill>
-                  <a:srgbClr val="8A8984"/>
-                </a:solidFill>
-                <a:latin typeface="Calibri" pitchFamily="34" charset="0"/>
-                <a:ea typeface="Calibri" pitchFamily="34" charset="-122"/>
-                <a:cs typeface="Calibri" pitchFamily="34" charset="-120"/>
-              </a:rPr>
-              <a:t>5</a:t>
-            </a:r>
-            <a:endParaRPr lang="en-US" sz="1200" dirty="0"/>
-          </a:p>
-        </p:txBody>
-      </p:sp>
-      <p:sp>
-        <p:nvSpPr>
-          <p:cNvPr id="39" name="Shape 36"/>
-          <p:cNvSpPr/>
-          <p:nvPr/>
-        </p:nvSpPr>
-        <p:spPr>
-          <a:xfrm>
-            <a:off x="5669280" y="2715768"/>
-            <a:ext cx="2331720" cy="475488"/>
-          </a:xfrm>
-          <a:prstGeom prst="roundRect">
-            <a:avLst>
-              <a:gd name="adj" fmla="val 15385"/>
-            </a:avLst>
-          </a:prstGeom>
-          <a:solidFill>
-            <a:srgbClr val="FFFFFF"/>
-          </a:solidFill>
-          <a:ln w="9525">
-            <a:solidFill>
-              <a:srgbClr val="E7E5E4"/>
-            </a:solidFill>
-            <a:prstDash val="solid"/>
-          </a:ln>
-        </p:spPr>
-      </p:sp>
-      <p:sp>
-        <p:nvSpPr>
-          <p:cNvPr id="40" name="Text 37"/>
-          <p:cNvSpPr/>
-          <p:nvPr/>
-        </p:nvSpPr>
-        <p:spPr>
-          <a:xfrm>
-            <a:off x="5806440" y="2843784"/>
-            <a:ext cx="1920240" cy="274320"/>
-          </a:xfrm>
-          <a:prstGeom prst="rect">
-            <a:avLst/>
-          </a:prstGeom>
-          <a:noFill/>
-          <a:ln/>
-        </p:spPr>
-        <p:txBody>
-          <a:bodyPr wrap="square" lIns="0" tIns="0" rIns="0" bIns="0" rtlCol="0" anchor="t"/>
-          <a:lstStyle/>
-          <a:p>
-            <a:pPr indent="0" marL="0">
-              <a:buNone/>
-            </a:pPr>
-            <a:r>
-              <a:rPr lang="en-US" sz="1200" b="1" dirty="0">
-                <a:solidFill>
-                  <a:srgbClr val="1A1A1A"/>
-                </a:solidFill>
-                <a:latin typeface="Calibri" pitchFamily="34" charset="0"/>
-                <a:ea typeface="Calibri" pitchFamily="34" charset="-122"/>
-                <a:cs typeface="Calibri" pitchFamily="34" charset="-120"/>
-              </a:rPr>
-              <a:t>HU08  </a:t>
-            </a:r>
-            <a:pPr indent="0" marL="0">
-              <a:buNone/>
-            </a:pPr>
-            <a:r>
-              <a:rPr lang="en-US" sz="1200" dirty="0">
-                <a:solidFill>
-                  <a:srgbClr val="1A1A1A"/>
-                </a:solidFill>
-                <a:latin typeface="Calibri" pitchFamily="34" charset="0"/>
-                <a:ea typeface="Calibri" pitchFamily="34" charset="-122"/>
-                <a:cs typeface="Calibri" pitchFamily="34" charset="-120"/>
-              </a:rPr>
-              <a:t>Clasificar la conducta</a:t>
-            </a:r>
-            <a:endParaRPr lang="en-US" sz="1200" dirty="0"/>
-          </a:p>
-        </p:txBody>
-      </p:sp>
-      <p:sp>
-        <p:nvSpPr>
-          <p:cNvPr id="41" name="Text 38"/>
-          <p:cNvSpPr/>
-          <p:nvPr/>
-        </p:nvSpPr>
-        <p:spPr>
-          <a:xfrm>
-            <a:off x="7635240" y="2843784"/>
-            <a:ext cx="256032" cy="274320"/>
-          </a:xfrm>
-          <a:prstGeom prst="rect">
-            <a:avLst/>
-          </a:prstGeom>
-          <a:noFill/>
-          <a:ln/>
-        </p:spPr>
-        <p:txBody>
-          <a:bodyPr wrap="square" lIns="0" tIns="0" rIns="0" bIns="0" rtlCol="0" anchor="t"/>
-          <a:lstStyle/>
-          <a:p>
-            <a:pPr algn="r" indent="0" marL="0">
-              <a:buNone/>
-            </a:pPr>
-            <a:r>
-              <a:rPr lang="en-US" sz="1200" dirty="0">
-                <a:solidFill>
-                  <a:srgbClr val="8A8984"/>
-                </a:solidFill>
-                <a:latin typeface="Calibri" pitchFamily="34" charset="0"/>
-                <a:ea typeface="Calibri" pitchFamily="34" charset="-122"/>
-                <a:cs typeface="Calibri" pitchFamily="34" charset="-120"/>
-              </a:rPr>
-              <a:t>3</a:t>
-            </a:r>
-            <a:endParaRPr lang="en-US" sz="1200" dirty="0"/>
-          </a:p>
-        </p:txBody>
-      </p:sp>
-      <p:sp>
-        <p:nvSpPr>
-          <p:cNvPr id="42" name="Shape 39"/>
-          <p:cNvSpPr/>
-          <p:nvPr/>
-        </p:nvSpPr>
-        <p:spPr>
-          <a:xfrm>
-            <a:off x="5669280" y="3282696"/>
-            <a:ext cx="2331720" cy="475488"/>
-          </a:xfrm>
-          <a:prstGeom prst="roundRect">
-            <a:avLst>
-              <a:gd name="adj" fmla="val 15385"/>
-            </a:avLst>
-          </a:prstGeom>
-          <a:solidFill>
-            <a:srgbClr val="FFFFFF"/>
-          </a:solidFill>
-          <a:ln w="9525">
-            <a:solidFill>
-              <a:srgbClr val="E7E5E4"/>
-            </a:solidFill>
-            <a:prstDash val="solid"/>
-          </a:ln>
-        </p:spPr>
-      </p:sp>
-      <p:sp>
-        <p:nvSpPr>
-          <p:cNvPr id="43" name="Text 40"/>
-          <p:cNvSpPr/>
-          <p:nvPr/>
-        </p:nvSpPr>
-        <p:spPr>
-          <a:xfrm>
-            <a:off x="5806440" y="3410712"/>
-            <a:ext cx="1920240" cy="274320"/>
-          </a:xfrm>
-          <a:prstGeom prst="rect">
-            <a:avLst/>
-          </a:prstGeom>
-          <a:noFill/>
-          <a:ln/>
-        </p:spPr>
-        <p:txBody>
-          <a:bodyPr wrap="square" lIns="0" tIns="0" rIns="0" bIns="0" rtlCol="0" anchor="t"/>
-          <a:lstStyle/>
-          <a:p>
-            <a:pPr indent="0" marL="0">
-              <a:buNone/>
-            </a:pPr>
-            <a:r>
-              <a:rPr lang="en-US" sz="1200" b="1" dirty="0">
-                <a:solidFill>
-                  <a:srgbClr val="1A1A1A"/>
-                </a:solidFill>
-                <a:latin typeface="Calibri" pitchFamily="34" charset="0"/>
-                <a:ea typeface="Calibri" pitchFamily="34" charset="-122"/>
-                <a:cs typeface="Calibri" pitchFamily="34" charset="-120"/>
-              </a:rPr>
-              <a:t>HU09  </a:t>
-            </a:r>
-            <a:pPr indent="0" marL="0">
-              <a:buNone/>
-            </a:pPr>
-            <a:r>
-              <a:rPr lang="en-US" sz="1200" dirty="0">
-                <a:solidFill>
-                  <a:srgbClr val="1A1A1A"/>
-                </a:solidFill>
-                <a:latin typeface="Calibri" pitchFamily="34" charset="0"/>
-                <a:ea typeface="Calibri" pitchFamily="34" charset="-122"/>
-                <a:cs typeface="Calibri" pitchFamily="34" charset="-120"/>
-              </a:rPr>
-              <a:t>Recuadro de riesgo</a:t>
-            </a:r>
-            <a:endParaRPr lang="en-US" sz="1200" dirty="0"/>
-          </a:p>
-        </p:txBody>
-      </p:sp>
-      <p:sp>
-        <p:nvSpPr>
-          <p:cNvPr id="44" name="Text 41"/>
-          <p:cNvSpPr/>
-          <p:nvPr/>
-        </p:nvSpPr>
-        <p:spPr>
-          <a:xfrm>
-            <a:off x="7635240" y="3410712"/>
-            <a:ext cx="256032" cy="274320"/>
-          </a:xfrm>
-          <a:prstGeom prst="rect">
-            <a:avLst/>
-          </a:prstGeom>
-          <a:noFill/>
-          <a:ln/>
-        </p:spPr>
-        <p:txBody>
-          <a:bodyPr wrap="square" lIns="0" tIns="0" rIns="0" bIns="0" rtlCol="0" anchor="t"/>
-          <a:lstStyle/>
-          <a:p>
-            <a:pPr algn="r" indent="0" marL="0">
-              <a:buNone/>
-            </a:pPr>
-            <a:r>
-              <a:rPr lang="en-US" sz="1200" dirty="0">
-                <a:solidFill>
-                  <a:srgbClr val="8A8984"/>
-                </a:solidFill>
-                <a:latin typeface="Calibri" pitchFamily="34" charset="0"/>
-                <a:ea typeface="Calibri" pitchFamily="34" charset="-122"/>
-                <a:cs typeface="Calibri" pitchFamily="34" charset="-120"/>
-              </a:rPr>
-              <a:t>4</a:t>
-            </a:r>
-            <a:endParaRPr lang="en-US" sz="1200" dirty="0"/>
-          </a:p>
-        </p:txBody>
-      </p:sp>
-      <p:sp>
-        <p:nvSpPr>
-          <p:cNvPr id="45" name="Shape 42"/>
-          <p:cNvSpPr/>
-          <p:nvPr/>
-        </p:nvSpPr>
-        <p:spPr>
-          <a:xfrm>
-            <a:off x="5669280" y="3849624"/>
-            <a:ext cx="2331720" cy="475488"/>
-          </a:xfrm>
-          <a:prstGeom prst="roundRect">
-            <a:avLst>
-              <a:gd name="adj" fmla="val 15385"/>
-            </a:avLst>
-          </a:prstGeom>
-          <a:solidFill>
-            <a:srgbClr val="FFFFFF"/>
-          </a:solidFill>
-          <a:ln w="9525">
-            <a:solidFill>
-              <a:srgbClr val="E7E5E4"/>
-            </a:solidFill>
-            <a:prstDash val="solid"/>
-          </a:ln>
-        </p:spPr>
-      </p:sp>
-      <p:sp>
-        <p:nvSpPr>
-          <p:cNvPr id="46" name="Text 43"/>
-          <p:cNvSpPr/>
-          <p:nvPr/>
-        </p:nvSpPr>
-        <p:spPr>
-          <a:xfrm>
-            <a:off x="5806440" y="3977640"/>
-            <a:ext cx="1920240" cy="274320"/>
-          </a:xfrm>
-          <a:prstGeom prst="rect">
-            <a:avLst/>
-          </a:prstGeom>
-          <a:noFill/>
-          <a:ln/>
-        </p:spPr>
-        <p:txBody>
-          <a:bodyPr wrap="square" lIns="0" tIns="0" rIns="0" bIns="0" rtlCol="0" anchor="t"/>
-          <a:lstStyle/>
-          <a:p>
-            <a:pPr indent="0" marL="0">
-              <a:buNone/>
-            </a:pPr>
-            <a:r>
-              <a:rPr lang="en-US" sz="1200" b="1" dirty="0">
-                <a:solidFill>
-                  <a:srgbClr val="1A1A1A"/>
-                </a:solidFill>
-                <a:latin typeface="Calibri" pitchFamily="34" charset="0"/>
-                <a:ea typeface="Calibri" pitchFamily="34" charset="-122"/>
-                <a:cs typeface="Calibri" pitchFamily="34" charset="-120"/>
-              </a:rPr>
-              <a:t>HU10  </a:t>
-            </a:r>
-            <a:pPr indent="0" marL="0">
-              <a:buNone/>
-            </a:pPr>
-            <a:r>
-              <a:rPr lang="en-US" sz="1200" dirty="0">
-                <a:solidFill>
-                  <a:srgbClr val="1A1A1A"/>
-                </a:solidFill>
-                <a:latin typeface="Calibri" pitchFamily="34" charset="0"/>
-                <a:ea typeface="Calibri" pitchFamily="34" charset="-122"/>
-                <a:cs typeface="Calibri" pitchFamily="34" charset="-120"/>
-              </a:rPr>
-              <a:t>Alerta de riesgo</a:t>
-            </a:r>
-            <a:endParaRPr lang="en-US" sz="1200" dirty="0"/>
-          </a:p>
-        </p:txBody>
-      </p:sp>
-      <p:sp>
-        <p:nvSpPr>
-          <p:cNvPr id="47" name="Text 44"/>
-          <p:cNvSpPr/>
-          <p:nvPr/>
-        </p:nvSpPr>
-        <p:spPr>
-          <a:xfrm>
-            <a:off x="7635240" y="3977640"/>
-            <a:ext cx="256032" cy="274320"/>
-          </a:xfrm>
-          <a:prstGeom prst="rect">
-            <a:avLst/>
-          </a:prstGeom>
-          <a:noFill/>
-          <a:ln/>
-        </p:spPr>
-        <p:txBody>
-          <a:bodyPr wrap="square" lIns="0" tIns="0" rIns="0" bIns="0" rtlCol="0" anchor="t"/>
-          <a:lstStyle/>
-          <a:p>
-            <a:pPr algn="r" indent="0" marL="0">
-              <a:buNone/>
-            </a:pPr>
-            <a:r>
-              <a:rPr lang="en-US" sz="1200" dirty="0">
-                <a:solidFill>
-                  <a:srgbClr val="8A8984"/>
-                </a:solidFill>
-                <a:latin typeface="Calibri" pitchFamily="34" charset="0"/>
-                <a:ea typeface="Calibri" pitchFamily="34" charset="-122"/>
-                <a:cs typeface="Calibri" pitchFamily="34" charset="-120"/>
-              </a:rPr>
-              <a:t>2</a:t>
-            </a:r>
-            <a:endParaRPr lang="en-US" sz="1200" dirty="0"/>
-          </a:p>
-        </p:txBody>
-      </p:sp>
-      <p:sp>
-        <p:nvSpPr>
-          <p:cNvPr id="48" name="Shape 45"/>
-          <p:cNvSpPr/>
-          <p:nvPr/>
-        </p:nvSpPr>
-        <p:spPr>
-          <a:xfrm>
-            <a:off x="5669280" y="4416552"/>
-            <a:ext cx="2331720" cy="475488"/>
-          </a:xfrm>
-          <a:prstGeom prst="roundRect">
-            <a:avLst>
-              <a:gd name="adj" fmla="val 15385"/>
-            </a:avLst>
-          </a:prstGeom>
-          <a:solidFill>
-            <a:srgbClr val="FFFFFF"/>
-          </a:solidFill>
-          <a:ln w="9525">
-            <a:solidFill>
-              <a:srgbClr val="E7E5E4"/>
-            </a:solidFill>
-            <a:prstDash val="solid"/>
-          </a:ln>
-        </p:spPr>
-      </p:sp>
-      <p:sp>
-        <p:nvSpPr>
-          <p:cNvPr id="49" name="Text 46"/>
-          <p:cNvSpPr/>
-          <p:nvPr/>
-        </p:nvSpPr>
-        <p:spPr>
-          <a:xfrm>
-            <a:off x="5806440" y="4544568"/>
-            <a:ext cx="1920240" cy="274320"/>
-          </a:xfrm>
-          <a:prstGeom prst="rect">
-            <a:avLst/>
-          </a:prstGeom>
-          <a:noFill/>
-          <a:ln/>
-        </p:spPr>
-        <p:txBody>
-          <a:bodyPr wrap="square" lIns="0" tIns="0" rIns="0" bIns="0" rtlCol="0" anchor="t"/>
-          <a:lstStyle/>
-          <a:p>
-            <a:pPr indent="0" marL="0">
-              <a:buNone/>
-            </a:pPr>
-            <a:r>
-              <a:rPr lang="en-US" sz="1200" b="1" dirty="0">
-                <a:solidFill>
-                  <a:srgbClr val="1A1A1A"/>
-                </a:solidFill>
-                <a:latin typeface="Calibri" pitchFamily="34" charset="0"/>
-                <a:ea typeface="Calibri" pitchFamily="34" charset="-122"/>
-                <a:cs typeface="Calibri" pitchFamily="34" charset="-120"/>
-              </a:rPr>
-              <a:t>HU12  </a:t>
-            </a:r>
-            <a:pPr indent="0" marL="0">
-              <a:buNone/>
-            </a:pPr>
-            <a:r>
-              <a:rPr lang="en-US" sz="1200" dirty="0">
-                <a:solidFill>
-                  <a:srgbClr val="1A1A1A"/>
-                </a:solidFill>
-                <a:latin typeface="Calibri" pitchFamily="34" charset="0"/>
-                <a:ea typeface="Calibri" pitchFamily="34" charset="-122"/>
-                <a:cs typeface="Calibri" pitchFamily="34" charset="-120"/>
-              </a:rPr>
-              <a:t>Log de tiempos</a:t>
-            </a:r>
-            <a:endParaRPr lang="en-US" sz="1200" dirty="0"/>
-          </a:p>
-        </p:txBody>
-      </p:sp>
-      <p:sp>
-        <p:nvSpPr>
-          <p:cNvPr id="50" name="Text 47"/>
-          <p:cNvSpPr/>
-          <p:nvPr/>
-        </p:nvSpPr>
-        <p:spPr>
-          <a:xfrm>
-            <a:off x="7635240" y="4544568"/>
-            <a:ext cx="256032" cy="274320"/>
-          </a:xfrm>
-          <a:prstGeom prst="rect">
-            <a:avLst/>
-          </a:prstGeom>
-          <a:noFill/>
-          <a:ln/>
-        </p:spPr>
-        <p:txBody>
-          <a:bodyPr wrap="square" lIns="0" tIns="0" rIns="0" bIns="0" rtlCol="0" anchor="t"/>
-          <a:lstStyle/>
-          <a:p>
-            <a:pPr algn="r" indent="0" marL="0">
-              <a:buNone/>
-            </a:pPr>
-            <a:r>
-              <a:rPr lang="en-US" sz="1200" dirty="0">
-                <a:solidFill>
-                  <a:srgbClr val="8A8984"/>
-                </a:solidFill>
-                <a:latin typeface="Calibri" pitchFamily="34" charset="0"/>
-                <a:ea typeface="Calibri" pitchFamily="34" charset="-122"/>
-                <a:cs typeface="Calibri" pitchFamily="34" charset="-120"/>
-              </a:rPr>
-              <a:t>2</a:t>
             </a:r>
             <a:endParaRPr lang="en-US" sz="1200" dirty="0"/>
           </a:p>

</xml_diff>